<commit_message>
präsentation milestone 1 aktualisiert
</commit_message>
<xml_diff>
--- a/Dokumente/LookUpAI_Milestone1_Praesentation.pptx
+++ b/Dokumente/LookUpAI_Milestone1_Praesentation.pptx
@@ -188,7 +188,7 @@
           <a:noFill/>
           <a:extLst>
             <a:ext uri="{909E8E84-426E-40dd-AFC4-6F175D3DCCD1}">
-              <a14:hiddenFill xmlns="" xmlns:a14="http://schemas.microsoft.com/office/drawing/2010/main">
+              <a14:hiddenFill xmlns:a14="http://schemas.microsoft.com/office/drawing/2010/main" xmlns="">
                 <a:solidFill>
                   <a:srgbClr val="FFFFFF"/>
                 </a:solidFill>
@@ -247,7 +247,7 @@
             </a:ln>
             <a:extLst>
               <a:ext uri="{91240B29-F687-4f45-9708-019B960494DF}">
-                <a14:hiddenLine xmlns="" xmlns:a14="http://schemas.microsoft.com/office/drawing/2010/main" w="9525">
+                <a14:hiddenLine xmlns:a14="http://schemas.microsoft.com/office/drawing/2010/main" xmlns="" w="9525">
                   <a:solidFill>
                     <a:srgbClr val="000000"/>
                   </a:solidFill>
@@ -258,6 +258,13 @@
               </a:ext>
             </a:extLst>
           </p:spPr>
+          <p:txBody>
+            <a:bodyPr/>
+            <a:lstStyle/>
+            <a:p>
+              <a:endParaRPr lang="de-DE"/>
+            </a:p>
+          </p:txBody>
         </p:sp>
         <p:sp>
           <p:nvSpPr>
@@ -337,7 +344,7 @@
             </a:ln>
             <a:extLst>
               <a:ext uri="{91240B29-F687-4f45-9708-019B960494DF}">
-                <a14:hiddenLine xmlns="" xmlns:a14="http://schemas.microsoft.com/office/drawing/2010/main" w="9525">
+                <a14:hiddenLine xmlns:a14="http://schemas.microsoft.com/office/drawing/2010/main" xmlns="" w="9525">
                   <a:solidFill>
                     <a:srgbClr val="000000"/>
                   </a:solidFill>
@@ -348,6 +355,13 @@
               </a:ext>
             </a:extLst>
           </p:spPr>
+          <p:txBody>
+            <a:bodyPr/>
+            <a:lstStyle/>
+            <a:p>
+              <a:endParaRPr lang="de-DE"/>
+            </a:p>
+          </p:txBody>
         </p:sp>
         <p:sp>
           <p:nvSpPr>
@@ -427,7 +441,7 @@
             </a:ln>
             <a:extLst>
               <a:ext uri="{91240B29-F687-4f45-9708-019B960494DF}">
-                <a14:hiddenLine xmlns="" xmlns:a14="http://schemas.microsoft.com/office/drawing/2010/main" w="9525">
+                <a14:hiddenLine xmlns:a14="http://schemas.microsoft.com/office/drawing/2010/main" xmlns="" w="9525">
                   <a:solidFill>
                     <a:srgbClr val="000000"/>
                   </a:solidFill>
@@ -438,6 +452,13 @@
               </a:ext>
             </a:extLst>
           </p:spPr>
+          <p:txBody>
+            <a:bodyPr/>
+            <a:lstStyle/>
+            <a:p>
+              <a:endParaRPr lang="de-DE"/>
+            </a:p>
+          </p:txBody>
         </p:sp>
         <p:sp>
           <p:nvSpPr>
@@ -461,7 +482,7 @@
             </a:ln>
             <a:extLst>
               <a:ext uri="{91240B29-F687-4f45-9708-019B960494DF}">
-                <a14:hiddenLine xmlns="" xmlns:a14="http://schemas.microsoft.com/office/drawing/2010/main" w="9525">
+                <a14:hiddenLine xmlns:a14="http://schemas.microsoft.com/office/drawing/2010/main" xmlns="" w="9525">
                   <a:solidFill>
                     <a:srgbClr val="000000"/>
                   </a:solidFill>
@@ -472,6 +493,13 @@
               </a:ext>
             </a:extLst>
           </p:spPr>
+          <p:txBody>
+            <a:bodyPr/>
+            <a:lstStyle/>
+            <a:p>
+              <a:endParaRPr lang="de-DE"/>
+            </a:p>
+          </p:txBody>
         </p:sp>
         <p:sp>
           <p:nvSpPr>
@@ -551,7 +579,7 @@
             </a:ln>
             <a:extLst>
               <a:ext uri="{91240B29-F687-4f45-9708-019B960494DF}">
-                <a14:hiddenLine xmlns="" xmlns:a14="http://schemas.microsoft.com/office/drawing/2010/main" w="9525">
+                <a14:hiddenLine xmlns:a14="http://schemas.microsoft.com/office/drawing/2010/main" xmlns="" w="9525">
                   <a:solidFill>
                     <a:srgbClr val="000000"/>
                   </a:solidFill>
@@ -562,6 +590,13 @@
               </a:ext>
             </a:extLst>
           </p:spPr>
+          <p:txBody>
+            <a:bodyPr/>
+            <a:lstStyle/>
+            <a:p>
+              <a:endParaRPr lang="de-DE"/>
+            </a:p>
+          </p:txBody>
         </p:sp>
         <p:sp>
           <p:nvSpPr>
@@ -613,7 +648,7 @@
             </a:ln>
             <a:extLst>
               <a:ext uri="{91240B29-F687-4f45-9708-019B960494DF}">
-                <a14:hiddenLine xmlns="" xmlns:a14="http://schemas.microsoft.com/office/drawing/2010/main" w="9525">
+                <a14:hiddenLine xmlns:a14="http://schemas.microsoft.com/office/drawing/2010/main" xmlns="" w="9525">
                   <a:solidFill>
                     <a:srgbClr val="000000"/>
                   </a:solidFill>
@@ -624,6 +659,13 @@
               </a:ext>
             </a:extLst>
           </p:spPr>
+          <p:txBody>
+            <a:bodyPr/>
+            <a:lstStyle/>
+            <a:p>
+              <a:endParaRPr lang="de-DE"/>
+            </a:p>
+          </p:txBody>
         </p:sp>
         <p:sp>
           <p:nvSpPr>
@@ -675,7 +717,7 @@
             </a:ln>
             <a:extLst>
               <a:ext uri="{91240B29-F687-4f45-9708-019B960494DF}">
-                <a14:hiddenLine xmlns="" xmlns:a14="http://schemas.microsoft.com/office/drawing/2010/main" w="9525">
+                <a14:hiddenLine xmlns:a14="http://schemas.microsoft.com/office/drawing/2010/main" xmlns="" w="9525">
                   <a:solidFill>
                     <a:srgbClr val="000000"/>
                   </a:solidFill>
@@ -686,6 +728,13 @@
               </a:ext>
             </a:extLst>
           </p:spPr>
+          <p:txBody>
+            <a:bodyPr/>
+            <a:lstStyle/>
+            <a:p>
+              <a:endParaRPr lang="de-DE"/>
+            </a:p>
+          </p:txBody>
         </p:sp>
         <p:sp>
           <p:nvSpPr>
@@ -765,7 +814,7 @@
             </a:ln>
             <a:extLst>
               <a:ext uri="{91240B29-F687-4f45-9708-019B960494DF}">
-                <a14:hiddenLine xmlns="" xmlns:a14="http://schemas.microsoft.com/office/drawing/2010/main" w="9525">
+                <a14:hiddenLine xmlns:a14="http://schemas.microsoft.com/office/drawing/2010/main" xmlns="" w="9525">
                   <a:solidFill>
                     <a:srgbClr val="000000"/>
                   </a:solidFill>
@@ -776,6 +825,13 @@
               </a:ext>
             </a:extLst>
           </p:spPr>
+          <p:txBody>
+            <a:bodyPr/>
+            <a:lstStyle/>
+            <a:p>
+              <a:endParaRPr lang="de-DE"/>
+            </a:p>
+          </p:txBody>
         </p:sp>
         <p:sp>
           <p:nvSpPr>
@@ -827,7 +883,7 @@
             </a:ln>
             <a:extLst>
               <a:ext uri="{91240B29-F687-4f45-9708-019B960494DF}">
-                <a14:hiddenLine xmlns="" xmlns:a14="http://schemas.microsoft.com/office/drawing/2010/main" w="9525">
+                <a14:hiddenLine xmlns:a14="http://schemas.microsoft.com/office/drawing/2010/main" xmlns="" w="9525">
                   <a:solidFill>
                     <a:srgbClr val="000000"/>
                   </a:solidFill>
@@ -838,6 +894,13 @@
               </a:ext>
             </a:extLst>
           </p:spPr>
+          <p:txBody>
+            <a:bodyPr/>
+            <a:lstStyle/>
+            <a:p>
+              <a:endParaRPr lang="de-DE"/>
+            </a:p>
+          </p:txBody>
         </p:sp>
         <p:sp>
           <p:nvSpPr>
@@ -889,7 +952,7 @@
             </a:ln>
             <a:extLst>
               <a:ext uri="{91240B29-F687-4f45-9708-019B960494DF}">
-                <a14:hiddenLine xmlns="" xmlns:a14="http://schemas.microsoft.com/office/drawing/2010/main" w="9525">
+                <a14:hiddenLine xmlns:a14="http://schemas.microsoft.com/office/drawing/2010/main" xmlns="" w="9525">
                   <a:solidFill>
                     <a:srgbClr val="000000"/>
                   </a:solidFill>
@@ -900,6 +963,13 @@
               </a:ext>
             </a:extLst>
           </p:spPr>
+          <p:txBody>
+            <a:bodyPr/>
+            <a:lstStyle/>
+            <a:p>
+              <a:endParaRPr lang="de-DE"/>
+            </a:p>
+          </p:txBody>
         </p:sp>
         <p:sp>
           <p:nvSpPr>
@@ -979,7 +1049,7 @@
             </a:ln>
             <a:extLst>
               <a:ext uri="{91240B29-F687-4f45-9708-019B960494DF}">
-                <a14:hiddenLine xmlns="" xmlns:a14="http://schemas.microsoft.com/office/drawing/2010/main" w="9525">
+                <a14:hiddenLine xmlns:a14="http://schemas.microsoft.com/office/drawing/2010/main" xmlns="" w="9525">
                   <a:solidFill>
                     <a:srgbClr val="000000"/>
                   </a:solidFill>
@@ -990,6 +1060,13 @@
               </a:ext>
             </a:extLst>
           </p:spPr>
+          <p:txBody>
+            <a:bodyPr/>
+            <a:lstStyle/>
+            <a:p>
+              <a:endParaRPr lang="de-DE"/>
+            </a:p>
+          </p:txBody>
         </p:sp>
         <p:sp>
           <p:nvSpPr>
@@ -1069,7 +1146,7 @@
             </a:ln>
             <a:extLst>
               <a:ext uri="{91240B29-F687-4f45-9708-019B960494DF}">
-                <a14:hiddenLine xmlns="" xmlns:a14="http://schemas.microsoft.com/office/drawing/2010/main" w="9525">
+                <a14:hiddenLine xmlns:a14="http://schemas.microsoft.com/office/drawing/2010/main" xmlns="" w="9525">
                   <a:solidFill>
                     <a:srgbClr val="000000"/>
                   </a:solidFill>
@@ -1080,6 +1157,13 @@
               </a:ext>
             </a:extLst>
           </p:spPr>
+          <p:txBody>
+            <a:bodyPr/>
+            <a:lstStyle/>
+            <a:p>
+              <a:endParaRPr lang="de-DE"/>
+            </a:p>
+          </p:txBody>
         </p:sp>
         <p:sp>
           <p:nvSpPr>
@@ -1131,7 +1215,7 @@
             </a:ln>
             <a:extLst>
               <a:ext uri="{91240B29-F687-4f45-9708-019B960494DF}">
-                <a14:hiddenLine xmlns="" xmlns:a14="http://schemas.microsoft.com/office/drawing/2010/main" w="9525">
+                <a14:hiddenLine xmlns:a14="http://schemas.microsoft.com/office/drawing/2010/main" xmlns="" w="9525">
                   <a:solidFill>
                     <a:srgbClr val="000000"/>
                   </a:solidFill>
@@ -1142,6 +1226,13 @@
               </a:ext>
             </a:extLst>
           </p:spPr>
+          <p:txBody>
+            <a:bodyPr/>
+            <a:lstStyle/>
+            <a:p>
+              <a:endParaRPr lang="de-DE"/>
+            </a:p>
+          </p:txBody>
         </p:sp>
         <p:sp>
           <p:nvSpPr>
@@ -1241,7 +1332,7 @@
             </a:ln>
             <a:extLst>
               <a:ext uri="{91240B29-F687-4f45-9708-019B960494DF}">
-                <a14:hiddenLine xmlns="" xmlns:a14="http://schemas.microsoft.com/office/drawing/2010/main" w="9525">
+                <a14:hiddenLine xmlns:a14="http://schemas.microsoft.com/office/drawing/2010/main" xmlns="" w="9525">
                   <a:solidFill>
                     <a:srgbClr val="000000"/>
                   </a:solidFill>
@@ -1252,6 +1343,13 @@
               </a:ext>
             </a:extLst>
           </p:spPr>
+          <p:txBody>
+            <a:bodyPr/>
+            <a:lstStyle/>
+            <a:p>
+              <a:endParaRPr lang="de-DE"/>
+            </a:p>
+          </p:txBody>
         </p:sp>
         <p:sp>
           <p:nvSpPr>
@@ -1303,7 +1401,7 @@
             </a:ln>
             <a:extLst>
               <a:ext uri="{91240B29-F687-4f45-9708-019B960494DF}">
-                <a14:hiddenLine xmlns="" xmlns:a14="http://schemas.microsoft.com/office/drawing/2010/main" w="9525">
+                <a14:hiddenLine xmlns:a14="http://schemas.microsoft.com/office/drawing/2010/main" xmlns="" w="9525">
                   <a:solidFill>
                     <a:srgbClr val="000000"/>
                   </a:solidFill>
@@ -1314,6 +1412,13 @@
               </a:ext>
             </a:extLst>
           </p:spPr>
+          <p:txBody>
+            <a:bodyPr/>
+            <a:lstStyle/>
+            <a:p>
+              <a:endParaRPr lang="de-DE"/>
+            </a:p>
+          </p:txBody>
         </p:sp>
         <p:sp>
           <p:nvSpPr>
@@ -1393,7 +1498,7 @@
             </a:ln>
             <a:extLst>
               <a:ext uri="{91240B29-F687-4f45-9708-019B960494DF}">
-                <a14:hiddenLine xmlns="" xmlns:a14="http://schemas.microsoft.com/office/drawing/2010/main" w="9525">
+                <a14:hiddenLine xmlns:a14="http://schemas.microsoft.com/office/drawing/2010/main" xmlns="" w="9525">
                   <a:solidFill>
                     <a:srgbClr val="000000"/>
                   </a:solidFill>
@@ -1404,6 +1509,13 @@
               </a:ext>
             </a:extLst>
           </p:spPr>
+          <p:txBody>
+            <a:bodyPr/>
+            <a:lstStyle/>
+            <a:p>
+              <a:endParaRPr lang="de-DE"/>
+            </a:p>
+          </p:txBody>
         </p:sp>
         <p:sp>
           <p:nvSpPr>
@@ -1483,7 +1595,7 @@
             </a:ln>
             <a:extLst>
               <a:ext uri="{91240B29-F687-4f45-9708-019B960494DF}">
-                <a14:hiddenLine xmlns="" xmlns:a14="http://schemas.microsoft.com/office/drawing/2010/main" w="9525">
+                <a14:hiddenLine xmlns:a14="http://schemas.microsoft.com/office/drawing/2010/main" xmlns="" w="9525">
                   <a:solidFill>
                     <a:srgbClr val="000000"/>
                   </a:solidFill>
@@ -1494,6 +1606,13 @@
               </a:ext>
             </a:extLst>
           </p:spPr>
+          <p:txBody>
+            <a:bodyPr/>
+            <a:lstStyle/>
+            <a:p>
+              <a:endParaRPr lang="de-DE"/>
+            </a:p>
+          </p:txBody>
         </p:sp>
         <p:sp>
           <p:nvSpPr>
@@ -1545,7 +1664,7 @@
             </a:ln>
             <a:extLst>
               <a:ext uri="{91240B29-F687-4f45-9708-019B960494DF}">
-                <a14:hiddenLine xmlns="" xmlns:a14="http://schemas.microsoft.com/office/drawing/2010/main" w="9525">
+                <a14:hiddenLine xmlns:a14="http://schemas.microsoft.com/office/drawing/2010/main" xmlns="" w="9525">
                   <a:solidFill>
                     <a:srgbClr val="000000"/>
                   </a:solidFill>
@@ -1556,6 +1675,13 @@
               </a:ext>
             </a:extLst>
           </p:spPr>
+          <p:txBody>
+            <a:bodyPr/>
+            <a:lstStyle/>
+            <a:p>
+              <a:endParaRPr lang="de-DE"/>
+            </a:p>
+          </p:txBody>
         </p:sp>
         <p:sp>
           <p:nvSpPr>
@@ -1635,7 +1761,7 @@
             </a:ln>
             <a:extLst>
               <a:ext uri="{91240B29-F687-4f45-9708-019B960494DF}">
-                <a14:hiddenLine xmlns="" xmlns:a14="http://schemas.microsoft.com/office/drawing/2010/main" w="9525">
+                <a14:hiddenLine xmlns:a14="http://schemas.microsoft.com/office/drawing/2010/main" xmlns="" w="9525">
                   <a:solidFill>
                     <a:srgbClr val="000000"/>
                   </a:solidFill>
@@ -1646,6 +1772,13 @@
               </a:ext>
             </a:extLst>
           </p:spPr>
+          <p:txBody>
+            <a:bodyPr/>
+            <a:lstStyle/>
+            <a:p>
+              <a:endParaRPr lang="de-DE"/>
+            </a:p>
+          </p:txBody>
         </p:sp>
         <p:sp>
           <p:nvSpPr>
@@ -1725,7 +1858,7 @@
             </a:ln>
             <a:extLst>
               <a:ext uri="{91240B29-F687-4f45-9708-019B960494DF}">
-                <a14:hiddenLine xmlns="" xmlns:a14="http://schemas.microsoft.com/office/drawing/2010/main" w="9525">
+                <a14:hiddenLine xmlns:a14="http://schemas.microsoft.com/office/drawing/2010/main" xmlns="" w="9525">
                   <a:solidFill>
                     <a:srgbClr val="000000"/>
                   </a:solidFill>
@@ -1736,6 +1869,13 @@
               </a:ext>
             </a:extLst>
           </p:spPr>
+          <p:txBody>
+            <a:bodyPr/>
+            <a:lstStyle/>
+            <a:p>
+              <a:endParaRPr lang="de-DE"/>
+            </a:p>
+          </p:txBody>
         </p:sp>
         <p:sp>
           <p:nvSpPr>
@@ -1781,7 +1921,7 @@
             </a:ln>
             <a:extLst>
               <a:ext uri="{91240B29-F687-4f45-9708-019B960494DF}">
-                <a14:hiddenLine xmlns="" xmlns:a14="http://schemas.microsoft.com/office/drawing/2010/main" w="9525">
+                <a14:hiddenLine xmlns:a14="http://schemas.microsoft.com/office/drawing/2010/main" xmlns="" w="9525">
                   <a:solidFill>
                     <a:srgbClr val="000000"/>
                   </a:solidFill>
@@ -1792,6 +1932,13 @@
               </a:ext>
             </a:extLst>
           </p:spPr>
+          <p:txBody>
+            <a:bodyPr/>
+            <a:lstStyle/>
+            <a:p>
+              <a:endParaRPr lang="de-DE"/>
+            </a:p>
+          </p:txBody>
         </p:sp>
         <p:sp>
           <p:nvSpPr>
@@ -1871,7 +2018,7 @@
             </a:ln>
             <a:extLst>
               <a:ext uri="{91240B29-F687-4f45-9708-019B960494DF}">
-                <a14:hiddenLine xmlns="" xmlns:a14="http://schemas.microsoft.com/office/drawing/2010/main" w="9525">
+                <a14:hiddenLine xmlns:a14="http://schemas.microsoft.com/office/drawing/2010/main" xmlns="" w="9525">
                   <a:solidFill>
                     <a:srgbClr val="000000"/>
                   </a:solidFill>
@@ -1882,6 +2029,13 @@
               </a:ext>
             </a:extLst>
           </p:spPr>
+          <p:txBody>
+            <a:bodyPr/>
+            <a:lstStyle/>
+            <a:p>
+              <a:endParaRPr lang="de-DE"/>
+            </a:p>
+          </p:txBody>
         </p:sp>
         <p:sp>
           <p:nvSpPr>
@@ -1927,7 +2081,7 @@
             </a:ln>
             <a:extLst>
               <a:ext uri="{91240B29-F687-4f45-9708-019B960494DF}">
-                <a14:hiddenLine xmlns="" xmlns:a14="http://schemas.microsoft.com/office/drawing/2010/main" w="9525">
+                <a14:hiddenLine xmlns:a14="http://schemas.microsoft.com/office/drawing/2010/main" xmlns="" w="9525">
                   <a:solidFill>
                     <a:srgbClr val="000000"/>
                   </a:solidFill>
@@ -1938,6 +2092,13 @@
               </a:ext>
             </a:extLst>
           </p:spPr>
+          <p:txBody>
+            <a:bodyPr/>
+            <a:lstStyle/>
+            <a:p>
+              <a:endParaRPr lang="de-DE"/>
+            </a:p>
+          </p:txBody>
         </p:sp>
         <p:sp>
           <p:nvSpPr>
@@ -2017,7 +2178,7 @@
             </a:ln>
             <a:extLst>
               <a:ext uri="{91240B29-F687-4f45-9708-019B960494DF}">
-                <a14:hiddenLine xmlns="" xmlns:a14="http://schemas.microsoft.com/office/drawing/2010/main" w="9525">
+                <a14:hiddenLine xmlns:a14="http://schemas.microsoft.com/office/drawing/2010/main" xmlns="" w="9525">
                   <a:solidFill>
                     <a:srgbClr val="000000"/>
                   </a:solidFill>
@@ -2028,6 +2189,13 @@
               </a:ext>
             </a:extLst>
           </p:spPr>
+          <p:txBody>
+            <a:bodyPr/>
+            <a:lstStyle/>
+            <a:p>
+              <a:endParaRPr lang="de-DE"/>
+            </a:p>
+          </p:txBody>
         </p:sp>
         <p:sp>
           <p:nvSpPr>
@@ -2085,7 +2253,7 @@
             </a:ln>
             <a:extLst>
               <a:ext uri="{91240B29-F687-4f45-9708-019B960494DF}">
-                <a14:hiddenLine xmlns="" xmlns:a14="http://schemas.microsoft.com/office/drawing/2010/main" w="9525">
+                <a14:hiddenLine xmlns:a14="http://schemas.microsoft.com/office/drawing/2010/main" xmlns="" w="9525">
                   <a:solidFill>
                     <a:srgbClr val="000000"/>
                   </a:solidFill>
@@ -2096,6 +2264,13 @@
               </a:ext>
             </a:extLst>
           </p:spPr>
+          <p:txBody>
+            <a:bodyPr/>
+            <a:lstStyle/>
+            <a:p>
+              <a:endParaRPr lang="de-DE"/>
+            </a:p>
+          </p:txBody>
         </p:sp>
         <p:sp>
           <p:nvSpPr>
@@ -2175,7 +2350,7 @@
             </a:ln>
             <a:extLst>
               <a:ext uri="{91240B29-F687-4f45-9708-019B960494DF}">
-                <a14:hiddenLine xmlns="" xmlns:a14="http://schemas.microsoft.com/office/drawing/2010/main" w="9525">
+                <a14:hiddenLine xmlns:a14="http://schemas.microsoft.com/office/drawing/2010/main" xmlns="" w="9525">
                   <a:solidFill>
                     <a:srgbClr val="000000"/>
                   </a:solidFill>
@@ -2186,6 +2361,13 @@
               </a:ext>
             </a:extLst>
           </p:spPr>
+          <p:txBody>
+            <a:bodyPr/>
+            <a:lstStyle/>
+            <a:p>
+              <a:endParaRPr lang="de-DE"/>
+            </a:p>
+          </p:txBody>
         </p:sp>
         <p:sp>
           <p:nvSpPr>
@@ -2243,7 +2425,7 @@
             </a:ln>
             <a:extLst>
               <a:ext uri="{91240B29-F687-4f45-9708-019B960494DF}">
-                <a14:hiddenLine xmlns="" xmlns:a14="http://schemas.microsoft.com/office/drawing/2010/main" w="9525">
+                <a14:hiddenLine xmlns:a14="http://schemas.microsoft.com/office/drawing/2010/main" xmlns="" w="9525">
                   <a:solidFill>
                     <a:srgbClr val="000000"/>
                   </a:solidFill>
@@ -2254,6 +2436,13 @@
               </a:ext>
             </a:extLst>
           </p:spPr>
+          <p:txBody>
+            <a:bodyPr/>
+            <a:lstStyle/>
+            <a:p>
+              <a:endParaRPr lang="de-DE"/>
+            </a:p>
+          </p:txBody>
         </p:sp>
         <p:sp>
           <p:nvSpPr>
@@ -2333,7 +2522,7 @@
             </a:ln>
             <a:extLst>
               <a:ext uri="{91240B29-F687-4f45-9708-019B960494DF}">
-                <a14:hiddenLine xmlns="" xmlns:a14="http://schemas.microsoft.com/office/drawing/2010/main" w="9525">
+                <a14:hiddenLine xmlns:a14="http://schemas.microsoft.com/office/drawing/2010/main" xmlns="" w="9525">
                   <a:solidFill>
                     <a:srgbClr val="000000"/>
                   </a:solidFill>
@@ -2344,6 +2533,13 @@
               </a:ext>
             </a:extLst>
           </p:spPr>
+          <p:txBody>
+            <a:bodyPr/>
+            <a:lstStyle/>
+            <a:p>
+              <a:endParaRPr lang="de-DE"/>
+            </a:p>
+          </p:txBody>
         </p:sp>
         <p:sp>
           <p:nvSpPr>
@@ -2367,7 +2563,7 @@
             </a:ln>
             <a:extLst>
               <a:ext uri="{91240B29-F687-4f45-9708-019B960494DF}">
-                <a14:hiddenLine xmlns="" xmlns:a14="http://schemas.microsoft.com/office/drawing/2010/main" w="9525">
+                <a14:hiddenLine xmlns:a14="http://schemas.microsoft.com/office/drawing/2010/main" xmlns="" w="9525">
                   <a:solidFill>
                     <a:srgbClr val="000000"/>
                   </a:solidFill>
@@ -2378,6 +2574,13 @@
               </a:ext>
             </a:extLst>
           </p:spPr>
+          <p:txBody>
+            <a:bodyPr/>
+            <a:lstStyle/>
+            <a:p>
+              <a:endParaRPr lang="de-DE"/>
+            </a:p>
+          </p:txBody>
         </p:sp>
         <p:sp>
           <p:nvSpPr>
@@ -2457,7 +2660,7 @@
             </a:ln>
             <a:extLst>
               <a:ext uri="{91240B29-F687-4f45-9708-019B960494DF}">
-                <a14:hiddenLine xmlns="" xmlns:a14="http://schemas.microsoft.com/office/drawing/2010/main" w="9525">
+                <a14:hiddenLine xmlns:a14="http://schemas.microsoft.com/office/drawing/2010/main" xmlns="" w="9525">
                   <a:solidFill>
                     <a:srgbClr val="000000"/>
                   </a:solidFill>
@@ -2468,6 +2671,13 @@
               </a:ext>
             </a:extLst>
           </p:spPr>
+          <p:txBody>
+            <a:bodyPr/>
+            <a:lstStyle/>
+            <a:p>
+              <a:endParaRPr lang="de-DE"/>
+            </a:p>
+          </p:txBody>
         </p:sp>
         <p:sp>
           <p:nvSpPr>
@@ -2519,7 +2729,7 @@
             </a:ln>
             <a:extLst>
               <a:ext uri="{91240B29-F687-4f45-9708-019B960494DF}">
-                <a14:hiddenLine xmlns="" xmlns:a14="http://schemas.microsoft.com/office/drawing/2010/main" w="9525">
+                <a14:hiddenLine xmlns:a14="http://schemas.microsoft.com/office/drawing/2010/main" xmlns="" w="9525">
                   <a:solidFill>
                     <a:srgbClr val="000000"/>
                   </a:solidFill>
@@ -2530,6 +2740,13 @@
               </a:ext>
             </a:extLst>
           </p:spPr>
+          <p:txBody>
+            <a:bodyPr/>
+            <a:lstStyle/>
+            <a:p>
+              <a:endParaRPr lang="de-DE"/>
+            </a:p>
+          </p:txBody>
         </p:sp>
         <p:sp>
           <p:nvSpPr>
@@ -2581,7 +2798,7 @@
             </a:ln>
             <a:extLst>
               <a:ext uri="{91240B29-F687-4f45-9708-019B960494DF}">
-                <a14:hiddenLine xmlns="" xmlns:a14="http://schemas.microsoft.com/office/drawing/2010/main" w="9525">
+                <a14:hiddenLine xmlns:a14="http://schemas.microsoft.com/office/drawing/2010/main" xmlns="" w="9525">
                   <a:solidFill>
                     <a:srgbClr val="000000"/>
                   </a:solidFill>
@@ -2592,6 +2809,13 @@
               </a:ext>
             </a:extLst>
           </p:spPr>
+          <p:txBody>
+            <a:bodyPr/>
+            <a:lstStyle/>
+            <a:p>
+              <a:endParaRPr lang="de-DE"/>
+            </a:p>
+          </p:txBody>
         </p:sp>
         <p:sp>
           <p:nvSpPr>
@@ -2671,7 +2895,7 @@
             </a:ln>
             <a:extLst>
               <a:ext uri="{91240B29-F687-4f45-9708-019B960494DF}">
-                <a14:hiddenLine xmlns="" xmlns:a14="http://schemas.microsoft.com/office/drawing/2010/main" w="9525">
+                <a14:hiddenLine xmlns:a14="http://schemas.microsoft.com/office/drawing/2010/main" xmlns="" w="9525">
                   <a:solidFill>
                     <a:srgbClr val="000000"/>
                   </a:solidFill>
@@ -2682,6 +2906,13 @@
               </a:ext>
             </a:extLst>
           </p:spPr>
+          <p:txBody>
+            <a:bodyPr/>
+            <a:lstStyle/>
+            <a:p>
+              <a:endParaRPr lang="de-DE"/>
+            </a:p>
+          </p:txBody>
         </p:sp>
         <p:sp>
           <p:nvSpPr>
@@ -2739,7 +2970,7 @@
             </a:ln>
             <a:extLst>
               <a:ext uri="{91240B29-F687-4f45-9708-019B960494DF}">
-                <a14:hiddenLine xmlns="" xmlns:a14="http://schemas.microsoft.com/office/drawing/2010/main" w="9525">
+                <a14:hiddenLine xmlns:a14="http://schemas.microsoft.com/office/drawing/2010/main" xmlns="" w="9525">
                   <a:solidFill>
                     <a:srgbClr val="000000"/>
                   </a:solidFill>
@@ -2750,6 +2981,13 @@
               </a:ext>
             </a:extLst>
           </p:spPr>
+          <p:txBody>
+            <a:bodyPr/>
+            <a:lstStyle/>
+            <a:p>
+              <a:endParaRPr lang="de-DE"/>
+            </a:p>
+          </p:txBody>
         </p:sp>
         <p:sp>
           <p:nvSpPr>
@@ -2801,7 +3039,7 @@
             </a:ln>
             <a:extLst>
               <a:ext uri="{91240B29-F687-4f45-9708-019B960494DF}">
-                <a14:hiddenLine xmlns="" xmlns:a14="http://schemas.microsoft.com/office/drawing/2010/main" w="9525">
+                <a14:hiddenLine xmlns:a14="http://schemas.microsoft.com/office/drawing/2010/main" xmlns="" w="9525">
                   <a:solidFill>
                     <a:srgbClr val="000000"/>
                   </a:solidFill>
@@ -2812,6 +3050,13 @@
               </a:ext>
             </a:extLst>
           </p:spPr>
+          <p:txBody>
+            <a:bodyPr/>
+            <a:lstStyle/>
+            <a:p>
+              <a:endParaRPr lang="de-DE"/>
+            </a:p>
+          </p:txBody>
         </p:sp>
         <p:sp>
           <p:nvSpPr>
@@ -2891,7 +3136,7 @@
             </a:ln>
             <a:extLst>
               <a:ext uri="{91240B29-F687-4f45-9708-019B960494DF}">
-                <a14:hiddenLine xmlns="" xmlns:a14="http://schemas.microsoft.com/office/drawing/2010/main" w="9525">
+                <a14:hiddenLine xmlns:a14="http://schemas.microsoft.com/office/drawing/2010/main" xmlns="" w="9525">
                   <a:solidFill>
                     <a:srgbClr val="000000"/>
                   </a:solidFill>
@@ -2902,6 +3147,13 @@
               </a:ext>
             </a:extLst>
           </p:spPr>
+          <p:txBody>
+            <a:bodyPr/>
+            <a:lstStyle/>
+            <a:p>
+              <a:endParaRPr lang="de-DE"/>
+            </a:p>
+          </p:txBody>
         </p:sp>
         <p:sp>
           <p:nvSpPr>
@@ -2953,7 +3205,7 @@
             </a:ln>
             <a:extLst>
               <a:ext uri="{91240B29-F687-4f45-9708-019B960494DF}">
-                <a14:hiddenLine xmlns="" xmlns:a14="http://schemas.microsoft.com/office/drawing/2010/main" w="9525">
+                <a14:hiddenLine xmlns:a14="http://schemas.microsoft.com/office/drawing/2010/main" xmlns="" w="9525">
                   <a:solidFill>
                     <a:srgbClr val="000000"/>
                   </a:solidFill>
@@ -2964,6 +3216,13 @@
               </a:ext>
             </a:extLst>
           </p:spPr>
+          <p:txBody>
+            <a:bodyPr/>
+            <a:lstStyle/>
+            <a:p>
+              <a:endParaRPr lang="de-DE"/>
+            </a:p>
+          </p:txBody>
         </p:sp>
         <p:sp>
           <p:nvSpPr>
@@ -3043,7 +3302,7 @@
             </a:ln>
             <a:extLst>
               <a:ext uri="{91240B29-F687-4f45-9708-019B960494DF}">
-                <a14:hiddenLine xmlns="" xmlns:a14="http://schemas.microsoft.com/office/drawing/2010/main" w="9525">
+                <a14:hiddenLine xmlns:a14="http://schemas.microsoft.com/office/drawing/2010/main" xmlns="" w="9525">
                   <a:solidFill>
                     <a:srgbClr val="000000"/>
                   </a:solidFill>
@@ -3054,6 +3313,13 @@
               </a:ext>
             </a:extLst>
           </p:spPr>
+          <p:txBody>
+            <a:bodyPr/>
+            <a:lstStyle/>
+            <a:p>
+              <a:endParaRPr lang="de-DE"/>
+            </a:p>
+          </p:txBody>
         </p:sp>
         <p:sp>
           <p:nvSpPr>
@@ -3105,7 +3371,7 @@
             </a:ln>
             <a:extLst>
               <a:ext uri="{91240B29-F687-4f45-9708-019B960494DF}">
-                <a14:hiddenLine xmlns="" xmlns:a14="http://schemas.microsoft.com/office/drawing/2010/main" w="9525">
+                <a14:hiddenLine xmlns:a14="http://schemas.microsoft.com/office/drawing/2010/main" xmlns="" w="9525">
                   <a:solidFill>
                     <a:srgbClr val="000000"/>
                   </a:solidFill>
@@ -3116,6 +3382,13 @@
               </a:ext>
             </a:extLst>
           </p:spPr>
+          <p:txBody>
+            <a:bodyPr/>
+            <a:lstStyle/>
+            <a:p>
+              <a:endParaRPr lang="de-DE"/>
+            </a:p>
+          </p:txBody>
         </p:sp>
         <p:sp>
           <p:nvSpPr>
@@ -3195,7 +3468,7 @@
             </a:ln>
             <a:extLst>
               <a:ext uri="{91240B29-F687-4f45-9708-019B960494DF}">
-                <a14:hiddenLine xmlns="" xmlns:a14="http://schemas.microsoft.com/office/drawing/2010/main" w="9525">
+                <a14:hiddenLine xmlns:a14="http://schemas.microsoft.com/office/drawing/2010/main" xmlns="" w="9525">
                   <a:solidFill>
                     <a:srgbClr val="000000"/>
                   </a:solidFill>
@@ -3206,6 +3479,13 @@
               </a:ext>
             </a:extLst>
           </p:spPr>
+          <p:txBody>
+            <a:bodyPr/>
+            <a:lstStyle/>
+            <a:p>
+              <a:endParaRPr lang="de-DE"/>
+            </a:p>
+          </p:txBody>
         </p:sp>
         <p:sp>
           <p:nvSpPr>
@@ -3229,7 +3509,7 @@
             </a:ln>
             <a:extLst>
               <a:ext uri="{91240B29-F687-4f45-9708-019B960494DF}">
-                <a14:hiddenLine xmlns="" xmlns:a14="http://schemas.microsoft.com/office/drawing/2010/main" w="9525">
+                <a14:hiddenLine xmlns:a14="http://schemas.microsoft.com/office/drawing/2010/main" xmlns="" w="9525">
                   <a:solidFill>
                     <a:srgbClr val="000000"/>
                   </a:solidFill>
@@ -3240,6 +3520,13 @@
               </a:ext>
             </a:extLst>
           </p:spPr>
+          <p:txBody>
+            <a:bodyPr/>
+            <a:lstStyle/>
+            <a:p>
+              <a:endParaRPr lang="de-DE"/>
+            </a:p>
+          </p:txBody>
         </p:sp>
         <p:sp>
           <p:nvSpPr>
@@ -3294,7 +3581,7 @@
             </a:ln>
             <a:extLst>
               <a:ext uri="{91240B29-F687-4f45-9708-019B960494DF}">
-                <a14:hiddenLine xmlns="" xmlns:a14="http://schemas.microsoft.com/office/drawing/2010/main" w="9525">
+                <a14:hiddenLine xmlns:a14="http://schemas.microsoft.com/office/drawing/2010/main" xmlns="" w="9525">
                   <a:solidFill>
                     <a:srgbClr val="000000"/>
                   </a:solidFill>
@@ -3305,6 +3592,13 @@
               </a:ext>
             </a:extLst>
           </p:spPr>
+          <p:txBody>
+            <a:bodyPr/>
+            <a:lstStyle/>
+            <a:p>
+              <a:endParaRPr lang="de-DE"/>
+            </a:p>
+          </p:txBody>
         </p:sp>
         <p:sp>
           <p:nvSpPr>
@@ -3384,7 +3678,7 @@
             </a:ln>
             <a:extLst>
               <a:ext uri="{91240B29-F687-4f45-9708-019B960494DF}">
-                <a14:hiddenLine xmlns="" xmlns:a14="http://schemas.microsoft.com/office/drawing/2010/main" w="9525">
+                <a14:hiddenLine xmlns:a14="http://schemas.microsoft.com/office/drawing/2010/main" xmlns="" w="9525">
                   <a:solidFill>
                     <a:srgbClr val="000000"/>
                   </a:solidFill>
@@ -3395,6 +3689,13 @@
               </a:ext>
             </a:extLst>
           </p:spPr>
+          <p:txBody>
+            <a:bodyPr/>
+            <a:lstStyle/>
+            <a:p>
+              <a:endParaRPr lang="de-DE"/>
+            </a:p>
+          </p:txBody>
         </p:sp>
         <p:sp>
           <p:nvSpPr>
@@ -3446,7 +3747,7 @@
             </a:ln>
             <a:extLst>
               <a:ext uri="{91240B29-F687-4f45-9708-019B960494DF}">
-                <a14:hiddenLine xmlns="" xmlns:a14="http://schemas.microsoft.com/office/drawing/2010/main" w="9525">
+                <a14:hiddenLine xmlns:a14="http://schemas.microsoft.com/office/drawing/2010/main" xmlns="" w="9525">
                   <a:solidFill>
                     <a:srgbClr val="000000"/>
                   </a:solidFill>
@@ -3457,6 +3758,13 @@
               </a:ext>
             </a:extLst>
           </p:spPr>
+          <p:txBody>
+            <a:bodyPr/>
+            <a:lstStyle/>
+            <a:p>
+              <a:endParaRPr lang="de-DE"/>
+            </a:p>
+          </p:txBody>
         </p:sp>
         <p:sp>
           <p:nvSpPr>
@@ -3536,7 +3844,7 @@
             </a:ln>
             <a:extLst>
               <a:ext uri="{91240B29-F687-4f45-9708-019B960494DF}">
-                <a14:hiddenLine xmlns="" xmlns:a14="http://schemas.microsoft.com/office/drawing/2010/main" w="9525">
+                <a14:hiddenLine xmlns:a14="http://schemas.microsoft.com/office/drawing/2010/main" xmlns="" w="9525">
                   <a:solidFill>
                     <a:srgbClr val="000000"/>
                   </a:solidFill>
@@ -3547,6 +3855,13 @@
               </a:ext>
             </a:extLst>
           </p:spPr>
+          <p:txBody>
+            <a:bodyPr/>
+            <a:lstStyle/>
+            <a:p>
+              <a:endParaRPr lang="de-DE"/>
+            </a:p>
+          </p:txBody>
         </p:sp>
         <p:sp>
           <p:nvSpPr>
@@ -3626,7 +3941,7 @@
             </a:ln>
             <a:extLst>
               <a:ext uri="{91240B29-F687-4f45-9708-019B960494DF}">
-                <a14:hiddenLine xmlns="" xmlns:a14="http://schemas.microsoft.com/office/drawing/2010/main" w="9525">
+                <a14:hiddenLine xmlns:a14="http://schemas.microsoft.com/office/drawing/2010/main" xmlns="" w="9525">
                   <a:solidFill>
                     <a:srgbClr val="000000"/>
                   </a:solidFill>
@@ -3637,6 +3952,13 @@
               </a:ext>
             </a:extLst>
           </p:spPr>
+          <p:txBody>
+            <a:bodyPr/>
+            <a:lstStyle/>
+            <a:p>
+              <a:endParaRPr lang="de-DE"/>
+            </a:p>
+          </p:txBody>
         </p:sp>
         <p:sp>
           <p:nvSpPr>
@@ -3691,7 +4013,7 @@
             </a:ln>
             <a:extLst>
               <a:ext uri="{91240B29-F687-4f45-9708-019B960494DF}">
-                <a14:hiddenLine xmlns="" xmlns:a14="http://schemas.microsoft.com/office/drawing/2010/main" w="9525">
+                <a14:hiddenLine xmlns:a14="http://schemas.microsoft.com/office/drawing/2010/main" xmlns="" w="9525">
                   <a:solidFill>
                     <a:srgbClr val="000000"/>
                   </a:solidFill>
@@ -3702,6 +4024,13 @@
               </a:ext>
             </a:extLst>
           </p:spPr>
+          <p:txBody>
+            <a:bodyPr/>
+            <a:lstStyle/>
+            <a:p>
+              <a:endParaRPr lang="de-DE"/>
+            </a:p>
+          </p:txBody>
         </p:sp>
         <p:sp>
           <p:nvSpPr>
@@ -3753,7 +4082,7 @@
             </a:ln>
             <a:extLst>
               <a:ext uri="{91240B29-F687-4f45-9708-019B960494DF}">
-                <a14:hiddenLine xmlns="" xmlns:a14="http://schemas.microsoft.com/office/drawing/2010/main" w="9525">
+                <a14:hiddenLine xmlns:a14="http://schemas.microsoft.com/office/drawing/2010/main" xmlns="" w="9525">
                   <a:solidFill>
                     <a:srgbClr val="000000"/>
                   </a:solidFill>
@@ -3764,6 +4093,13 @@
               </a:ext>
             </a:extLst>
           </p:spPr>
+          <p:txBody>
+            <a:bodyPr/>
+            <a:lstStyle/>
+            <a:p>
+              <a:endParaRPr lang="de-DE"/>
+            </a:p>
+          </p:txBody>
         </p:sp>
         <p:sp>
           <p:nvSpPr>
@@ -3843,7 +4179,7 @@
             </a:ln>
             <a:extLst>
               <a:ext uri="{91240B29-F687-4f45-9708-019B960494DF}">
-                <a14:hiddenLine xmlns="" xmlns:a14="http://schemas.microsoft.com/office/drawing/2010/main" w="9525">
+                <a14:hiddenLine xmlns:a14="http://schemas.microsoft.com/office/drawing/2010/main" xmlns="" w="9525">
                   <a:solidFill>
                     <a:srgbClr val="000000"/>
                   </a:solidFill>
@@ -3854,6 +4190,13 @@
               </a:ext>
             </a:extLst>
           </p:spPr>
+          <p:txBody>
+            <a:bodyPr/>
+            <a:lstStyle/>
+            <a:p>
+              <a:endParaRPr lang="de-DE"/>
+            </a:p>
+          </p:txBody>
         </p:sp>
         <p:sp>
           <p:nvSpPr>
@@ -3933,7 +4276,7 @@
             </a:ln>
             <a:extLst>
               <a:ext uri="{91240B29-F687-4f45-9708-019B960494DF}">
-                <a14:hiddenLine xmlns="" xmlns:a14="http://schemas.microsoft.com/office/drawing/2010/main" w="9525">
+                <a14:hiddenLine xmlns:a14="http://schemas.microsoft.com/office/drawing/2010/main" xmlns="" w="9525">
                   <a:solidFill>
                     <a:srgbClr val="000000"/>
                   </a:solidFill>
@@ -3944,6 +4287,13 @@
               </a:ext>
             </a:extLst>
           </p:spPr>
+          <p:txBody>
+            <a:bodyPr/>
+            <a:lstStyle/>
+            <a:p>
+              <a:endParaRPr lang="de-DE"/>
+            </a:p>
+          </p:txBody>
         </p:sp>
         <p:sp>
           <p:nvSpPr>
@@ -3995,7 +4345,7 @@
             </a:ln>
             <a:extLst>
               <a:ext uri="{91240B29-F687-4f45-9708-019B960494DF}">
-                <a14:hiddenLine xmlns="" xmlns:a14="http://schemas.microsoft.com/office/drawing/2010/main" w="9525">
+                <a14:hiddenLine xmlns:a14="http://schemas.microsoft.com/office/drawing/2010/main" xmlns="" w="9525">
                   <a:solidFill>
                     <a:srgbClr val="000000"/>
                   </a:solidFill>
@@ -4006,6 +4356,13 @@
               </a:ext>
             </a:extLst>
           </p:spPr>
+          <p:txBody>
+            <a:bodyPr/>
+            <a:lstStyle/>
+            <a:p>
+              <a:endParaRPr lang="de-DE"/>
+            </a:p>
+          </p:txBody>
         </p:sp>
         <p:sp>
           <p:nvSpPr>
@@ -4115,7 +4472,7 @@
             </a:ln>
             <a:extLst>
               <a:ext uri="{91240B29-F687-4f45-9708-019B960494DF}">
-                <a14:hiddenLine xmlns="" xmlns:a14="http://schemas.microsoft.com/office/drawing/2010/main" w="9525">
+                <a14:hiddenLine xmlns:a14="http://schemas.microsoft.com/office/drawing/2010/main" xmlns="" w="9525">
                   <a:solidFill>
                     <a:srgbClr val="000000"/>
                   </a:solidFill>
@@ -4126,6 +4483,13 @@
               </a:ext>
             </a:extLst>
           </p:spPr>
+          <p:txBody>
+            <a:bodyPr/>
+            <a:lstStyle/>
+            <a:p>
+              <a:endParaRPr lang="de-DE"/>
+            </a:p>
+          </p:txBody>
         </p:sp>
         <p:sp>
           <p:nvSpPr>
@@ -4183,7 +4547,7 @@
             </a:ln>
             <a:extLst>
               <a:ext uri="{91240B29-F687-4f45-9708-019B960494DF}">
-                <a14:hiddenLine xmlns="" xmlns:a14="http://schemas.microsoft.com/office/drawing/2010/main" w="9525">
+                <a14:hiddenLine xmlns:a14="http://schemas.microsoft.com/office/drawing/2010/main" xmlns="" w="9525">
                   <a:solidFill>
                     <a:srgbClr val="000000"/>
                   </a:solidFill>
@@ -4194,6 +4558,13 @@
               </a:ext>
             </a:extLst>
           </p:spPr>
+          <p:txBody>
+            <a:bodyPr/>
+            <a:lstStyle/>
+            <a:p>
+              <a:endParaRPr lang="de-DE"/>
+            </a:p>
+          </p:txBody>
         </p:sp>
         <p:sp>
           <p:nvSpPr>
@@ -4273,7 +4644,7 @@
             </a:ln>
             <a:extLst>
               <a:ext uri="{91240B29-F687-4f45-9708-019B960494DF}">
-                <a14:hiddenLine xmlns="" xmlns:a14="http://schemas.microsoft.com/office/drawing/2010/main" w="9525">
+                <a14:hiddenLine xmlns:a14="http://schemas.microsoft.com/office/drawing/2010/main" xmlns="" w="9525">
                   <a:solidFill>
                     <a:srgbClr val="000000"/>
                   </a:solidFill>
@@ -4284,6 +4655,13 @@
               </a:ext>
             </a:extLst>
           </p:spPr>
+          <p:txBody>
+            <a:bodyPr/>
+            <a:lstStyle/>
+            <a:p>
+              <a:endParaRPr lang="de-DE"/>
+            </a:p>
+          </p:txBody>
         </p:sp>
       </p:grpSp>
       <p:sp>
@@ -4481,13 +4859,13 @@
   <p:clrMapOvr>
     <a:masterClrMapping/>
   </p:clrMapOvr>
-  <mc:AlternateContent xmlns:mc="http://schemas.openxmlformats.org/markup-compatibility/2006">
-    <mc:Choice xmlns:p14="http://schemas.microsoft.com/office/powerpoint/2010/main" Requires="p14">
+  <mc:AlternateContent xmlns:mc="http://schemas.openxmlformats.org/markup-compatibility/2006" xmlns:p14="http://schemas.microsoft.com/office/powerpoint/2010/main">
+    <mc:Choice Requires="p14">
       <p:transition spd="slow" p14:dur="1600">
         <p14:gallery dir="l"/>
       </p:transition>
     </mc:Choice>
-    <mc:Fallback>
+    <mc:Fallback xmlns="">
       <p:transition spd="slow">
         <p:fade/>
       </p:transition>
@@ -4750,13 +5128,13 @@
   <p:clrMapOvr>
     <a:masterClrMapping/>
   </p:clrMapOvr>
-  <mc:AlternateContent xmlns:mc="http://schemas.openxmlformats.org/markup-compatibility/2006">
-    <mc:Choice xmlns:p14="http://schemas.microsoft.com/office/powerpoint/2010/main" Requires="p14">
+  <mc:AlternateContent xmlns:mc="http://schemas.openxmlformats.org/markup-compatibility/2006" xmlns:p14="http://schemas.microsoft.com/office/powerpoint/2010/main">
+    <mc:Choice Requires="p14">
       <p:transition spd="slow" p14:dur="1600">
         <p14:gallery dir="l"/>
       </p:transition>
     </mc:Choice>
-    <mc:Fallback>
+    <mc:Fallback xmlns="">
       <p:transition spd="slow">
         <p:fade/>
       </p:transition>
@@ -4958,13 +5336,13 @@
   <p:clrMapOvr>
     <a:masterClrMapping/>
   </p:clrMapOvr>
-  <mc:AlternateContent xmlns:mc="http://schemas.openxmlformats.org/markup-compatibility/2006">
-    <mc:Choice xmlns:p14="http://schemas.microsoft.com/office/powerpoint/2010/main" Requires="p14">
+  <mc:AlternateContent xmlns:mc="http://schemas.openxmlformats.org/markup-compatibility/2006" xmlns:p14="http://schemas.microsoft.com/office/powerpoint/2010/main">
+    <mc:Choice Requires="p14">
       <p:transition spd="slow" p14:dur="1600">
         <p14:gallery dir="l"/>
       </p:transition>
     </mc:Choice>
-    <mc:Fallback>
+    <mc:Fallback xmlns="">
       <p:transition spd="slow">
         <p:fade/>
       </p:transition>
@@ -5471,13 +5849,13 @@
   <p:clrMapOvr>
     <a:masterClrMapping/>
   </p:clrMapOvr>
-  <mc:AlternateContent xmlns:mc="http://schemas.openxmlformats.org/markup-compatibility/2006">
-    <mc:Choice xmlns:p14="http://schemas.microsoft.com/office/powerpoint/2010/main" Requires="p14">
+  <mc:AlternateContent xmlns:mc="http://schemas.openxmlformats.org/markup-compatibility/2006" xmlns:p14="http://schemas.microsoft.com/office/powerpoint/2010/main">
+    <mc:Choice Requires="p14">
       <p:transition spd="slow" p14:dur="1600">
         <p14:gallery dir="l"/>
       </p:transition>
     </mc:Choice>
-    <mc:Fallback>
+    <mc:Fallback xmlns="">
       <p:transition spd="slow">
         <p:fade/>
       </p:transition>
@@ -5679,13 +6057,13 @@
   <p:clrMapOvr>
     <a:masterClrMapping/>
   </p:clrMapOvr>
-  <mc:AlternateContent xmlns:mc="http://schemas.openxmlformats.org/markup-compatibility/2006">
-    <mc:Choice xmlns:p14="http://schemas.microsoft.com/office/powerpoint/2010/main" Requires="p14">
+  <mc:AlternateContent xmlns:mc="http://schemas.openxmlformats.org/markup-compatibility/2006" xmlns:p14="http://schemas.microsoft.com/office/powerpoint/2010/main">
+    <mc:Choice Requires="p14">
       <p:transition spd="slow" p14:dur="1600">
         <p14:gallery dir="l"/>
       </p:transition>
     </mc:Choice>
-    <mc:Fallback>
+    <mc:Fallback xmlns="">
       <p:transition spd="slow">
         <p:fade/>
       </p:transition>
@@ -6237,13 +6615,13 @@
   <p:clrMapOvr>
     <a:masterClrMapping/>
   </p:clrMapOvr>
-  <mc:AlternateContent xmlns:mc="http://schemas.openxmlformats.org/markup-compatibility/2006">
-    <mc:Choice xmlns:p14="http://schemas.microsoft.com/office/powerpoint/2010/main" Requires="p14">
+  <mc:AlternateContent xmlns:mc="http://schemas.openxmlformats.org/markup-compatibility/2006" xmlns:p14="http://schemas.microsoft.com/office/powerpoint/2010/main">
+    <mc:Choice Requires="p14">
       <p:transition spd="slow" p14:dur="1600">
         <p14:gallery dir="l"/>
       </p:transition>
     </mc:Choice>
-    <mc:Fallback>
+    <mc:Fallback xmlns="">
       <p:transition spd="slow">
         <p:fade/>
       </p:transition>
@@ -6973,13 +7351,13 @@
   <p:clrMapOvr>
     <a:masterClrMapping/>
   </p:clrMapOvr>
-  <mc:AlternateContent xmlns:mc="http://schemas.openxmlformats.org/markup-compatibility/2006">
-    <mc:Choice xmlns:p14="http://schemas.microsoft.com/office/powerpoint/2010/main" Requires="p14">
+  <mc:AlternateContent xmlns:mc="http://schemas.openxmlformats.org/markup-compatibility/2006" xmlns:p14="http://schemas.microsoft.com/office/powerpoint/2010/main">
+    <mc:Choice Requires="p14">
       <p:transition spd="slow" p14:dur="1600">
         <p14:gallery dir="l"/>
       </p:transition>
     </mc:Choice>
-    <mc:Fallback>
+    <mc:Fallback xmlns="">
       <p:transition spd="slow">
         <p:fade/>
       </p:transition>
@@ -7155,13 +7533,13 @@
   <p:clrMapOvr>
     <a:masterClrMapping/>
   </p:clrMapOvr>
-  <mc:AlternateContent xmlns:mc="http://schemas.openxmlformats.org/markup-compatibility/2006">
-    <mc:Choice xmlns:p14="http://schemas.microsoft.com/office/powerpoint/2010/main" Requires="p14">
+  <mc:AlternateContent xmlns:mc="http://schemas.openxmlformats.org/markup-compatibility/2006" xmlns:p14="http://schemas.microsoft.com/office/powerpoint/2010/main">
+    <mc:Choice Requires="p14">
       <p:transition spd="slow" p14:dur="1600">
         <p14:gallery dir="l"/>
       </p:transition>
     </mc:Choice>
-    <mc:Fallback>
+    <mc:Fallback xmlns="">
       <p:transition spd="slow">
         <p:fade/>
       </p:transition>
@@ -7347,13 +7725,13 @@
   <p:clrMapOvr>
     <a:masterClrMapping/>
   </p:clrMapOvr>
-  <mc:AlternateContent xmlns:mc="http://schemas.openxmlformats.org/markup-compatibility/2006">
-    <mc:Choice xmlns:p14="http://schemas.microsoft.com/office/powerpoint/2010/main" Requires="p14">
+  <mc:AlternateContent xmlns:mc="http://schemas.openxmlformats.org/markup-compatibility/2006" xmlns:p14="http://schemas.microsoft.com/office/powerpoint/2010/main">
+    <mc:Choice Requires="p14">
       <p:transition spd="slow" p14:dur="1600">
         <p14:gallery dir="l"/>
       </p:transition>
     </mc:Choice>
-    <mc:Fallback>
+    <mc:Fallback xmlns="">
       <p:transition spd="slow">
         <p:fade/>
       </p:transition>
@@ -7554,13 +7932,13 @@
   <p:clrMapOvr>
     <a:masterClrMapping/>
   </p:clrMapOvr>
-  <mc:AlternateContent xmlns:mc="http://schemas.openxmlformats.org/markup-compatibility/2006">
-    <mc:Choice xmlns:p14="http://schemas.microsoft.com/office/powerpoint/2010/main" Requires="p14">
+  <mc:AlternateContent xmlns:mc="http://schemas.openxmlformats.org/markup-compatibility/2006" xmlns:p14="http://schemas.microsoft.com/office/powerpoint/2010/main">
+    <mc:Choice Requires="p14">
       <p:transition spd="slow" p14:dur="1600">
         <p14:gallery dir="l"/>
       </p:transition>
     </mc:Choice>
-    <mc:Fallback>
+    <mc:Fallback xmlns="">
       <p:transition spd="slow">
         <p:fade/>
       </p:transition>
@@ -7816,13 +8194,13 @@
   <p:clrMapOvr>
     <a:masterClrMapping/>
   </p:clrMapOvr>
-  <mc:AlternateContent xmlns:mc="http://schemas.openxmlformats.org/markup-compatibility/2006">
-    <mc:Choice xmlns:p14="http://schemas.microsoft.com/office/powerpoint/2010/main" Requires="p14">
+  <mc:AlternateContent xmlns:mc="http://schemas.openxmlformats.org/markup-compatibility/2006" xmlns:p14="http://schemas.microsoft.com/office/powerpoint/2010/main">
+    <mc:Choice Requires="p14">
       <p:transition spd="slow" p14:dur="1600">
         <p14:gallery dir="l"/>
       </p:transition>
     </mc:Choice>
-    <mc:Fallback>
+    <mc:Fallback xmlns="">
       <p:transition spd="slow">
         <p:fade/>
       </p:transition>
@@ -8060,13 +8438,13 @@
   <p:clrMapOvr>
     <a:masterClrMapping/>
   </p:clrMapOvr>
-  <mc:AlternateContent xmlns:mc="http://schemas.openxmlformats.org/markup-compatibility/2006">
-    <mc:Choice xmlns:p14="http://schemas.microsoft.com/office/powerpoint/2010/main" Requires="p14">
+  <mc:AlternateContent xmlns:mc="http://schemas.openxmlformats.org/markup-compatibility/2006" xmlns:p14="http://schemas.microsoft.com/office/powerpoint/2010/main">
+    <mc:Choice Requires="p14">
       <p:transition spd="slow" p14:dur="1600">
         <p14:gallery dir="l"/>
       </p:transition>
     </mc:Choice>
-    <mc:Fallback>
+    <mc:Fallback xmlns="">
       <p:transition spd="slow">
         <p:fade/>
       </p:transition>
@@ -8453,13 +8831,13 @@
   <p:clrMapOvr>
     <a:masterClrMapping/>
   </p:clrMapOvr>
-  <mc:AlternateContent xmlns:mc="http://schemas.openxmlformats.org/markup-compatibility/2006">
-    <mc:Choice xmlns:p14="http://schemas.microsoft.com/office/powerpoint/2010/main" Requires="p14">
+  <mc:AlternateContent xmlns:mc="http://schemas.openxmlformats.org/markup-compatibility/2006" xmlns:p14="http://schemas.microsoft.com/office/powerpoint/2010/main">
+    <mc:Choice Requires="p14">
       <p:transition spd="slow" p14:dur="1600">
         <p14:gallery dir="l"/>
       </p:transition>
     </mc:Choice>
-    <mc:Fallback>
+    <mc:Fallback xmlns="">
       <p:transition spd="slow">
         <p:fade/>
       </p:transition>
@@ -8583,13 +8961,13 @@
   <p:clrMapOvr>
     <a:masterClrMapping/>
   </p:clrMapOvr>
-  <mc:AlternateContent xmlns:mc="http://schemas.openxmlformats.org/markup-compatibility/2006">
-    <mc:Choice xmlns:p14="http://schemas.microsoft.com/office/powerpoint/2010/main" Requires="p14">
+  <mc:AlternateContent xmlns:mc="http://schemas.openxmlformats.org/markup-compatibility/2006" xmlns:p14="http://schemas.microsoft.com/office/powerpoint/2010/main">
+    <mc:Choice Requires="p14">
       <p:transition spd="slow" p14:dur="1600">
         <p14:gallery dir="l"/>
       </p:transition>
     </mc:Choice>
-    <mc:Fallback>
+    <mc:Fallback xmlns="">
       <p:transition spd="slow">
         <p:fade/>
       </p:transition>
@@ -8690,13 +9068,13 @@
   <p:clrMapOvr>
     <a:masterClrMapping/>
   </p:clrMapOvr>
-  <mc:AlternateContent xmlns:mc="http://schemas.openxmlformats.org/markup-compatibility/2006">
-    <mc:Choice xmlns:p14="http://schemas.microsoft.com/office/powerpoint/2010/main" Requires="p14">
+  <mc:AlternateContent xmlns:mc="http://schemas.openxmlformats.org/markup-compatibility/2006" xmlns:p14="http://schemas.microsoft.com/office/powerpoint/2010/main">
+    <mc:Choice Requires="p14">
       <p:transition spd="slow" p14:dur="1600">
         <p14:gallery dir="l"/>
       </p:transition>
     </mc:Choice>
-    <mc:Fallback>
+    <mc:Fallback xmlns="">
       <p:transition spd="slow">
         <p:fade/>
       </p:transition>
@@ -8951,13 +9329,13 @@
   <p:clrMapOvr>
     <a:masterClrMapping/>
   </p:clrMapOvr>
-  <mc:AlternateContent xmlns:mc="http://schemas.openxmlformats.org/markup-compatibility/2006">
-    <mc:Choice xmlns:p14="http://schemas.microsoft.com/office/powerpoint/2010/main" Requires="p14">
+  <mc:AlternateContent xmlns:mc="http://schemas.openxmlformats.org/markup-compatibility/2006" xmlns:p14="http://schemas.microsoft.com/office/powerpoint/2010/main">
+    <mc:Choice Requires="p14">
       <p:transition spd="slow" p14:dur="1600">
         <p14:gallery dir="l"/>
       </p:transition>
     </mc:Choice>
-    <mc:Fallback>
+    <mc:Fallback xmlns="">
       <p:transition spd="slow">
         <p:fade/>
       </p:transition>
@@ -9215,13 +9593,13 @@
   <p:clrMapOvr>
     <a:masterClrMapping/>
   </p:clrMapOvr>
-  <mc:AlternateContent xmlns:mc="http://schemas.openxmlformats.org/markup-compatibility/2006">
-    <mc:Choice xmlns:p14="http://schemas.microsoft.com/office/powerpoint/2010/main" Requires="p14">
+  <mc:AlternateContent xmlns:mc="http://schemas.openxmlformats.org/markup-compatibility/2006" xmlns:p14="http://schemas.microsoft.com/office/powerpoint/2010/main">
+    <mc:Choice Requires="p14">
       <p:transition spd="slow" p14:dur="1600">
         <p14:gallery dir="l"/>
       </p:transition>
     </mc:Choice>
-    <mc:Fallback>
+    <mc:Fallback xmlns="">
       <p:transition spd="slow">
         <p:fade/>
       </p:transition>
@@ -9292,7 +9670,7 @@
           <a:noFill/>
           <a:extLst>
             <a:ext uri="{909E8E84-426E-40dd-AFC4-6F175D3DCCD1}">
-              <a14:hiddenFill xmlns="" xmlns:a14="http://schemas.microsoft.com/office/drawing/2010/main">
+              <a14:hiddenFill xmlns:a14="http://schemas.microsoft.com/office/drawing/2010/main" xmlns="">
                 <a:solidFill>
                   <a:srgbClr val="FFFFFF"/>
                 </a:solidFill>
@@ -9366,7 +9744,7 @@
               </a:ln>
               <a:extLst>
                 <a:ext uri="{91240B29-F687-4f45-9708-019B960494DF}">
-                  <a14:hiddenLine xmlns="" xmlns:a14="http://schemas.microsoft.com/office/drawing/2010/main" w="9525">
+                  <a14:hiddenLine xmlns:a14="http://schemas.microsoft.com/office/drawing/2010/main" xmlns="" w="9525">
                     <a:solidFill>
                       <a:srgbClr val="000000"/>
                     </a:solidFill>
@@ -9377,6 +9755,13 @@
                 </a:ext>
               </a:extLst>
             </p:spPr>
+            <p:txBody>
+              <a:bodyPr/>
+              <a:lstStyle/>
+              <a:p>
+                <a:endParaRPr lang="de-DE"/>
+              </a:p>
+            </p:txBody>
           </p:sp>
           <p:sp>
             <p:nvSpPr>
@@ -9456,7 +9841,7 @@
               </a:ln>
               <a:extLst>
                 <a:ext uri="{91240B29-F687-4f45-9708-019B960494DF}">
-                  <a14:hiddenLine xmlns="" xmlns:a14="http://schemas.microsoft.com/office/drawing/2010/main" w="9525">
+                  <a14:hiddenLine xmlns:a14="http://schemas.microsoft.com/office/drawing/2010/main" xmlns="" w="9525">
                     <a:solidFill>
                       <a:srgbClr val="000000"/>
                     </a:solidFill>
@@ -9467,6 +9852,13 @@
                 </a:ext>
               </a:extLst>
             </p:spPr>
+            <p:txBody>
+              <a:bodyPr/>
+              <a:lstStyle/>
+              <a:p>
+                <a:endParaRPr lang="de-DE"/>
+              </a:p>
+            </p:txBody>
           </p:sp>
           <p:sp>
             <p:nvSpPr>
@@ -9546,7 +9938,7 @@
               </a:ln>
               <a:extLst>
                 <a:ext uri="{91240B29-F687-4f45-9708-019B960494DF}">
-                  <a14:hiddenLine xmlns="" xmlns:a14="http://schemas.microsoft.com/office/drawing/2010/main" w="9525">
+                  <a14:hiddenLine xmlns:a14="http://schemas.microsoft.com/office/drawing/2010/main" xmlns="" w="9525">
                     <a:solidFill>
                       <a:srgbClr val="000000"/>
                     </a:solidFill>
@@ -9557,6 +9949,13 @@
                 </a:ext>
               </a:extLst>
             </p:spPr>
+            <p:txBody>
+              <a:bodyPr/>
+              <a:lstStyle/>
+              <a:p>
+                <a:endParaRPr lang="de-DE"/>
+              </a:p>
+            </p:txBody>
           </p:sp>
           <p:sp>
             <p:nvSpPr>
@@ -9608,7 +10007,7 @@
               </a:ln>
               <a:extLst>
                 <a:ext uri="{91240B29-F687-4f45-9708-019B960494DF}">
-                  <a14:hiddenLine xmlns="" xmlns:a14="http://schemas.microsoft.com/office/drawing/2010/main" w="9525">
+                  <a14:hiddenLine xmlns:a14="http://schemas.microsoft.com/office/drawing/2010/main" xmlns="" w="9525">
                     <a:solidFill>
                       <a:srgbClr val="000000"/>
                     </a:solidFill>
@@ -9619,6 +10018,13 @@
                 </a:ext>
               </a:extLst>
             </p:spPr>
+            <p:txBody>
+              <a:bodyPr/>
+              <a:lstStyle/>
+              <a:p>
+                <a:endParaRPr lang="de-DE"/>
+              </a:p>
+            </p:txBody>
           </p:sp>
           <p:sp>
             <p:nvSpPr>
@@ -9698,7 +10104,7 @@
               </a:ln>
               <a:extLst>
                 <a:ext uri="{91240B29-F687-4f45-9708-019B960494DF}">
-                  <a14:hiddenLine xmlns="" xmlns:a14="http://schemas.microsoft.com/office/drawing/2010/main" w="9525">
+                  <a14:hiddenLine xmlns:a14="http://schemas.microsoft.com/office/drawing/2010/main" xmlns="" w="9525">
                     <a:solidFill>
                       <a:srgbClr val="000000"/>
                     </a:solidFill>
@@ -9709,6 +10115,13 @@
                 </a:ext>
               </a:extLst>
             </p:spPr>
+            <p:txBody>
+              <a:bodyPr/>
+              <a:lstStyle/>
+              <a:p>
+                <a:endParaRPr lang="de-DE"/>
+              </a:p>
+            </p:txBody>
           </p:sp>
           <p:sp>
             <p:nvSpPr>
@@ -9760,7 +10173,7 @@
               </a:ln>
               <a:extLst>
                 <a:ext uri="{91240B29-F687-4f45-9708-019B960494DF}">
-                  <a14:hiddenLine xmlns="" xmlns:a14="http://schemas.microsoft.com/office/drawing/2010/main" w="9525">
+                  <a14:hiddenLine xmlns:a14="http://schemas.microsoft.com/office/drawing/2010/main" xmlns="" w="9525">
                     <a:solidFill>
                       <a:srgbClr val="000000"/>
                     </a:solidFill>
@@ -9771,6 +10184,13 @@
                 </a:ext>
               </a:extLst>
             </p:spPr>
+            <p:txBody>
+              <a:bodyPr/>
+              <a:lstStyle/>
+              <a:p>
+                <a:endParaRPr lang="de-DE"/>
+              </a:p>
+            </p:txBody>
           </p:sp>
           <p:sp>
             <p:nvSpPr>
@@ -9822,7 +10242,7 @@
               </a:ln>
               <a:extLst>
                 <a:ext uri="{91240B29-F687-4f45-9708-019B960494DF}">
-                  <a14:hiddenLine xmlns="" xmlns:a14="http://schemas.microsoft.com/office/drawing/2010/main" w="9525">
+                  <a14:hiddenLine xmlns:a14="http://schemas.microsoft.com/office/drawing/2010/main" xmlns="" w="9525">
                     <a:solidFill>
                       <a:srgbClr val="000000"/>
                     </a:solidFill>
@@ -9833,6 +10253,13 @@
                 </a:ext>
               </a:extLst>
             </p:spPr>
+            <p:txBody>
+              <a:bodyPr/>
+              <a:lstStyle/>
+              <a:p>
+                <a:endParaRPr lang="de-DE"/>
+              </a:p>
+            </p:txBody>
           </p:sp>
           <p:sp>
             <p:nvSpPr>
@@ -9912,7 +10339,7 @@
               </a:ln>
               <a:extLst>
                 <a:ext uri="{91240B29-F687-4f45-9708-019B960494DF}">
-                  <a14:hiddenLine xmlns="" xmlns:a14="http://schemas.microsoft.com/office/drawing/2010/main" w="9525">
+                  <a14:hiddenLine xmlns:a14="http://schemas.microsoft.com/office/drawing/2010/main" xmlns="" w="9525">
                     <a:solidFill>
                       <a:srgbClr val="000000"/>
                     </a:solidFill>
@@ -9923,6 +10350,13 @@
                 </a:ext>
               </a:extLst>
             </p:spPr>
+            <p:txBody>
+              <a:bodyPr/>
+              <a:lstStyle/>
+              <a:p>
+                <a:endParaRPr lang="de-DE"/>
+              </a:p>
+            </p:txBody>
           </p:sp>
           <p:sp>
             <p:nvSpPr>
@@ -10002,7 +10436,7 @@
               </a:ln>
               <a:extLst>
                 <a:ext uri="{91240B29-F687-4f45-9708-019B960494DF}">
-                  <a14:hiddenLine xmlns="" xmlns:a14="http://schemas.microsoft.com/office/drawing/2010/main" w="9525">
+                  <a14:hiddenLine xmlns:a14="http://schemas.microsoft.com/office/drawing/2010/main" xmlns="" w="9525">
                     <a:solidFill>
                       <a:srgbClr val="000000"/>
                     </a:solidFill>
@@ -10013,6 +10447,13 @@
                 </a:ext>
               </a:extLst>
             </p:spPr>
+            <p:txBody>
+              <a:bodyPr/>
+              <a:lstStyle/>
+              <a:p>
+                <a:endParaRPr lang="de-DE"/>
+              </a:p>
+            </p:txBody>
           </p:sp>
           <p:sp>
             <p:nvSpPr>
@@ -10064,7 +10505,7 @@
               </a:ln>
               <a:extLst>
                 <a:ext uri="{91240B29-F687-4f45-9708-019B960494DF}">
-                  <a14:hiddenLine xmlns="" xmlns:a14="http://schemas.microsoft.com/office/drawing/2010/main" w="9525">
+                  <a14:hiddenLine xmlns:a14="http://schemas.microsoft.com/office/drawing/2010/main" xmlns="" w="9525">
                     <a:solidFill>
                       <a:srgbClr val="000000"/>
                     </a:solidFill>
@@ -10075,6 +10516,13 @@
                 </a:ext>
               </a:extLst>
             </p:spPr>
+            <p:txBody>
+              <a:bodyPr/>
+              <a:lstStyle/>
+              <a:p>
+                <a:endParaRPr lang="de-DE"/>
+              </a:p>
+            </p:txBody>
           </p:sp>
           <p:sp>
             <p:nvSpPr>
@@ -10174,7 +10622,7 @@
               </a:ln>
               <a:extLst>
                 <a:ext uri="{91240B29-F687-4f45-9708-019B960494DF}">
-                  <a14:hiddenLine xmlns="" xmlns:a14="http://schemas.microsoft.com/office/drawing/2010/main" w="9525">
+                  <a14:hiddenLine xmlns:a14="http://schemas.microsoft.com/office/drawing/2010/main" xmlns="" w="9525">
                     <a:solidFill>
                       <a:srgbClr val="000000"/>
                     </a:solidFill>
@@ -10185,6 +10633,13 @@
                 </a:ext>
               </a:extLst>
             </p:spPr>
+            <p:txBody>
+              <a:bodyPr/>
+              <a:lstStyle/>
+              <a:p>
+                <a:endParaRPr lang="de-DE"/>
+              </a:p>
+            </p:txBody>
           </p:sp>
           <p:sp>
             <p:nvSpPr>
@@ -10213,6 +10668,13 @@
                 <a:tailEnd/>
               </a:ln>
             </p:spPr>
+            <p:txBody>
+              <a:bodyPr/>
+              <a:lstStyle/>
+              <a:p>
+                <a:endParaRPr lang="de-DE"/>
+              </a:p>
+            </p:txBody>
           </p:sp>
           <p:sp>
             <p:nvSpPr>
@@ -10258,7 +10720,7 @@
               </a:ln>
               <a:extLst>
                 <a:ext uri="{91240B29-F687-4f45-9708-019B960494DF}">
-                  <a14:hiddenLine xmlns="" xmlns:a14="http://schemas.microsoft.com/office/drawing/2010/main" w="9525">
+                  <a14:hiddenLine xmlns:a14="http://schemas.microsoft.com/office/drawing/2010/main" xmlns="" w="9525">
                     <a:solidFill>
                       <a:srgbClr val="000000"/>
                     </a:solidFill>
@@ -10269,6 +10731,13 @@
                 </a:ext>
               </a:extLst>
             </p:spPr>
+            <p:txBody>
+              <a:bodyPr/>
+              <a:lstStyle/>
+              <a:p>
+                <a:endParaRPr lang="de-DE"/>
+              </a:p>
+            </p:txBody>
           </p:sp>
           <p:sp>
             <p:nvSpPr>
@@ -10320,7 +10789,7 @@
               </a:ln>
               <a:extLst>
                 <a:ext uri="{91240B29-F687-4f45-9708-019B960494DF}">
-                  <a14:hiddenLine xmlns="" xmlns:a14="http://schemas.microsoft.com/office/drawing/2010/main" w="9525">
+                  <a14:hiddenLine xmlns:a14="http://schemas.microsoft.com/office/drawing/2010/main" xmlns="" w="9525">
                     <a:solidFill>
                       <a:srgbClr val="000000"/>
                     </a:solidFill>
@@ -10331,6 +10800,13 @@
                 </a:ext>
               </a:extLst>
             </p:spPr>
+            <p:txBody>
+              <a:bodyPr/>
+              <a:lstStyle/>
+              <a:p>
+                <a:endParaRPr lang="de-DE"/>
+              </a:p>
+            </p:txBody>
           </p:sp>
           <p:sp>
             <p:nvSpPr>
@@ -10382,7 +10858,7 @@
               </a:ln>
               <a:extLst>
                 <a:ext uri="{91240B29-F687-4f45-9708-019B960494DF}">
-                  <a14:hiddenLine xmlns="" xmlns:a14="http://schemas.microsoft.com/office/drawing/2010/main" w="9525">
+                  <a14:hiddenLine xmlns:a14="http://schemas.microsoft.com/office/drawing/2010/main" xmlns="" w="9525">
                     <a:solidFill>
                       <a:srgbClr val="000000"/>
                     </a:solidFill>
@@ -10393,6 +10869,13 @@
                 </a:ext>
               </a:extLst>
             </p:spPr>
+            <p:txBody>
+              <a:bodyPr/>
+              <a:lstStyle/>
+              <a:p>
+                <a:endParaRPr lang="de-DE"/>
+              </a:p>
+            </p:txBody>
           </p:sp>
           <p:sp>
             <p:nvSpPr>
@@ -10472,7 +10955,7 @@
               </a:ln>
               <a:extLst>
                 <a:ext uri="{91240B29-F687-4f45-9708-019B960494DF}">
-                  <a14:hiddenLine xmlns="" xmlns:a14="http://schemas.microsoft.com/office/drawing/2010/main" w="9525">
+                  <a14:hiddenLine xmlns:a14="http://schemas.microsoft.com/office/drawing/2010/main" xmlns="" w="9525">
                     <a:solidFill>
                       <a:srgbClr val="000000"/>
                     </a:solidFill>
@@ -10483,6 +10966,13 @@
                 </a:ext>
               </a:extLst>
             </p:spPr>
+            <p:txBody>
+              <a:bodyPr/>
+              <a:lstStyle/>
+              <a:p>
+                <a:endParaRPr lang="de-DE"/>
+              </a:p>
+            </p:txBody>
           </p:sp>
           <p:sp>
             <p:nvSpPr>
@@ -10506,7 +10996,7 @@
               </a:ln>
               <a:extLst>
                 <a:ext uri="{91240B29-F687-4f45-9708-019B960494DF}">
-                  <a14:hiddenLine xmlns="" xmlns:a14="http://schemas.microsoft.com/office/drawing/2010/main" w="9525">
+                  <a14:hiddenLine xmlns:a14="http://schemas.microsoft.com/office/drawing/2010/main" xmlns="" w="9525">
                     <a:solidFill>
                       <a:srgbClr val="000000"/>
                     </a:solidFill>
@@ -10517,6 +11007,13 @@
                 </a:ext>
               </a:extLst>
             </p:spPr>
+            <p:txBody>
+              <a:bodyPr/>
+              <a:lstStyle/>
+              <a:p>
+                <a:endParaRPr lang="de-DE"/>
+              </a:p>
+            </p:txBody>
           </p:sp>
           <p:sp>
             <p:nvSpPr>
@@ -10571,7 +11068,7 @@
               </a:ln>
               <a:extLst>
                 <a:ext uri="{91240B29-F687-4f45-9708-019B960494DF}">
-                  <a14:hiddenLine xmlns="" xmlns:a14="http://schemas.microsoft.com/office/drawing/2010/main" w="9525">
+                  <a14:hiddenLine xmlns:a14="http://schemas.microsoft.com/office/drawing/2010/main" xmlns="" w="9525">
                     <a:solidFill>
                       <a:srgbClr val="000000"/>
                     </a:solidFill>
@@ -10582,6 +11079,13 @@
                 </a:ext>
               </a:extLst>
             </p:spPr>
+            <p:txBody>
+              <a:bodyPr/>
+              <a:lstStyle/>
+              <a:p>
+                <a:endParaRPr lang="de-DE"/>
+              </a:p>
+            </p:txBody>
           </p:sp>
           <p:sp>
             <p:nvSpPr>
@@ -10661,7 +11165,7 @@
               </a:ln>
               <a:extLst>
                 <a:ext uri="{91240B29-F687-4f45-9708-019B960494DF}">
-                  <a14:hiddenLine xmlns="" xmlns:a14="http://schemas.microsoft.com/office/drawing/2010/main" w="9525">
+                  <a14:hiddenLine xmlns:a14="http://schemas.microsoft.com/office/drawing/2010/main" xmlns="" w="9525">
                     <a:solidFill>
                       <a:srgbClr val="000000"/>
                     </a:solidFill>
@@ -10672,6 +11176,13 @@
                 </a:ext>
               </a:extLst>
             </p:spPr>
+            <p:txBody>
+              <a:bodyPr/>
+              <a:lstStyle/>
+              <a:p>
+                <a:endParaRPr lang="de-DE"/>
+              </a:p>
+            </p:txBody>
           </p:sp>
           <p:sp>
             <p:nvSpPr>
@@ -10723,7 +11234,7 @@
               </a:ln>
               <a:extLst>
                 <a:ext uri="{91240B29-F687-4f45-9708-019B960494DF}">
-                  <a14:hiddenLine xmlns="" xmlns:a14="http://schemas.microsoft.com/office/drawing/2010/main" w="9525">
+                  <a14:hiddenLine xmlns:a14="http://schemas.microsoft.com/office/drawing/2010/main" xmlns="" w="9525">
                     <a:solidFill>
                       <a:srgbClr val="000000"/>
                     </a:solidFill>
@@ -10734,6 +11245,13 @@
                 </a:ext>
               </a:extLst>
             </p:spPr>
+            <p:txBody>
+              <a:bodyPr/>
+              <a:lstStyle/>
+              <a:p>
+                <a:endParaRPr lang="de-DE"/>
+              </a:p>
+            </p:txBody>
           </p:sp>
           <p:sp>
             <p:nvSpPr>
@@ -10813,7 +11331,7 @@
               </a:ln>
               <a:extLst>
                 <a:ext uri="{91240B29-F687-4f45-9708-019B960494DF}">
-                  <a14:hiddenLine xmlns="" xmlns:a14="http://schemas.microsoft.com/office/drawing/2010/main" w="9525">
+                  <a14:hiddenLine xmlns:a14="http://schemas.microsoft.com/office/drawing/2010/main" xmlns="" w="9525">
                     <a:solidFill>
                       <a:srgbClr val="000000"/>
                     </a:solidFill>
@@ -10824,6 +11342,13 @@
                 </a:ext>
               </a:extLst>
             </p:spPr>
+            <p:txBody>
+              <a:bodyPr/>
+              <a:lstStyle/>
+              <a:p>
+                <a:endParaRPr lang="de-DE"/>
+              </a:p>
+            </p:txBody>
           </p:sp>
           <p:sp>
             <p:nvSpPr>
@@ -10878,7 +11403,7 @@
               </a:ln>
               <a:extLst>
                 <a:ext uri="{91240B29-F687-4f45-9708-019B960494DF}">
-                  <a14:hiddenLine xmlns="" xmlns:a14="http://schemas.microsoft.com/office/drawing/2010/main" w="9525">
+                  <a14:hiddenLine xmlns:a14="http://schemas.microsoft.com/office/drawing/2010/main" xmlns="" w="9525">
                     <a:solidFill>
                       <a:srgbClr val="000000"/>
                     </a:solidFill>
@@ -10889,6 +11414,13 @@
                 </a:ext>
               </a:extLst>
             </p:spPr>
+            <p:txBody>
+              <a:bodyPr/>
+              <a:lstStyle/>
+              <a:p>
+                <a:endParaRPr lang="de-DE"/>
+              </a:p>
+            </p:txBody>
           </p:sp>
           <p:sp>
             <p:nvSpPr>
@@ -10940,7 +11472,7 @@
               </a:ln>
               <a:extLst>
                 <a:ext uri="{91240B29-F687-4f45-9708-019B960494DF}">
-                  <a14:hiddenLine xmlns="" xmlns:a14="http://schemas.microsoft.com/office/drawing/2010/main" w="9525">
+                  <a14:hiddenLine xmlns:a14="http://schemas.microsoft.com/office/drawing/2010/main" xmlns="" w="9525">
                     <a:solidFill>
                       <a:srgbClr val="000000"/>
                     </a:solidFill>
@@ -10951,6 +11483,13 @@
                 </a:ext>
               </a:extLst>
             </p:spPr>
+            <p:txBody>
+              <a:bodyPr/>
+              <a:lstStyle/>
+              <a:p>
+                <a:endParaRPr lang="de-DE"/>
+              </a:p>
+            </p:txBody>
           </p:sp>
           <p:sp>
             <p:nvSpPr>
@@ -11030,7 +11569,7 @@
               </a:ln>
               <a:extLst>
                 <a:ext uri="{91240B29-F687-4f45-9708-019B960494DF}">
-                  <a14:hiddenLine xmlns="" xmlns:a14="http://schemas.microsoft.com/office/drawing/2010/main" w="9525">
+                  <a14:hiddenLine xmlns:a14="http://schemas.microsoft.com/office/drawing/2010/main" xmlns="" w="9525">
                     <a:solidFill>
                       <a:srgbClr val="000000"/>
                     </a:solidFill>
@@ -11041,6 +11580,13 @@
                 </a:ext>
               </a:extLst>
             </p:spPr>
+            <p:txBody>
+              <a:bodyPr/>
+              <a:lstStyle/>
+              <a:p>
+                <a:endParaRPr lang="de-DE"/>
+              </a:p>
+            </p:txBody>
           </p:sp>
           <p:sp>
             <p:nvSpPr>
@@ -11120,7 +11666,7 @@
               </a:ln>
               <a:extLst>
                 <a:ext uri="{91240B29-F687-4f45-9708-019B960494DF}">
-                  <a14:hiddenLine xmlns="" xmlns:a14="http://schemas.microsoft.com/office/drawing/2010/main" w="9525">
+                  <a14:hiddenLine xmlns:a14="http://schemas.microsoft.com/office/drawing/2010/main" xmlns="" w="9525">
                     <a:solidFill>
                       <a:srgbClr val="000000"/>
                     </a:solidFill>
@@ -11131,6 +11677,13 @@
                 </a:ext>
               </a:extLst>
             </p:spPr>
+            <p:txBody>
+              <a:bodyPr/>
+              <a:lstStyle/>
+              <a:p>
+                <a:endParaRPr lang="de-DE"/>
+              </a:p>
+            </p:txBody>
           </p:sp>
           <p:sp>
             <p:nvSpPr>
@@ -11185,7 +11738,7 @@
               </a:ln>
               <a:extLst>
                 <a:ext uri="{91240B29-F687-4f45-9708-019B960494DF}">
-                  <a14:hiddenLine xmlns="" xmlns:a14="http://schemas.microsoft.com/office/drawing/2010/main" w="9525">
+                  <a14:hiddenLine xmlns:a14="http://schemas.microsoft.com/office/drawing/2010/main" xmlns="" w="9525">
                     <a:solidFill>
                       <a:srgbClr val="000000"/>
                     </a:solidFill>
@@ -11196,6 +11749,13 @@
                 </a:ext>
               </a:extLst>
             </p:spPr>
+            <p:txBody>
+              <a:bodyPr/>
+              <a:lstStyle/>
+              <a:p>
+                <a:endParaRPr lang="de-DE"/>
+              </a:p>
+            </p:txBody>
           </p:sp>
           <p:sp>
             <p:nvSpPr>
@@ -11305,7 +11865,7 @@
               </a:ln>
               <a:extLst>
                 <a:ext uri="{91240B29-F687-4f45-9708-019B960494DF}">
-                  <a14:hiddenLine xmlns="" xmlns:a14="http://schemas.microsoft.com/office/drawing/2010/main" w="9525">
+                  <a14:hiddenLine xmlns:a14="http://schemas.microsoft.com/office/drawing/2010/main" xmlns="" w="9525">
                     <a:solidFill>
                       <a:srgbClr val="000000"/>
                     </a:solidFill>
@@ -11316,6 +11876,13 @@
                 </a:ext>
               </a:extLst>
             </p:spPr>
+            <p:txBody>
+              <a:bodyPr/>
+              <a:lstStyle/>
+              <a:p>
+                <a:endParaRPr lang="de-DE"/>
+              </a:p>
+            </p:txBody>
           </p:sp>
         </p:grpSp>
         <p:grpSp>
@@ -11386,7 +11953,7 @@
               </a:ln>
               <a:extLst>
                 <a:ext uri="{91240B29-F687-4f45-9708-019B960494DF}">
-                  <a14:hiddenLine xmlns="" xmlns:a14="http://schemas.microsoft.com/office/drawing/2010/main" w="9525">
+                  <a14:hiddenLine xmlns:a14="http://schemas.microsoft.com/office/drawing/2010/main" xmlns="" w="9525">
                     <a:solidFill>
                       <a:srgbClr val="000000"/>
                     </a:solidFill>
@@ -11397,6 +11964,13 @@
                 </a:ext>
               </a:extLst>
             </p:spPr>
+            <p:txBody>
+              <a:bodyPr/>
+              <a:lstStyle/>
+              <a:p>
+                <a:endParaRPr lang="de-DE"/>
+              </a:p>
+            </p:txBody>
           </p:sp>
           <p:sp>
             <p:nvSpPr>
@@ -11501,7 +12075,7 @@
               </a:ln>
               <a:extLst>
                 <a:ext uri="{91240B29-F687-4f45-9708-019B960494DF}">
-                  <a14:hiddenLine xmlns="" xmlns:a14="http://schemas.microsoft.com/office/drawing/2010/main" w="9525">
+                  <a14:hiddenLine xmlns:a14="http://schemas.microsoft.com/office/drawing/2010/main" xmlns="" w="9525">
                     <a:solidFill>
                       <a:srgbClr val="000000"/>
                     </a:solidFill>
@@ -11512,6 +12086,13 @@
                 </a:ext>
               </a:extLst>
             </p:spPr>
+            <p:txBody>
+              <a:bodyPr/>
+              <a:lstStyle/>
+              <a:p>
+                <a:endParaRPr lang="de-DE"/>
+              </a:p>
+            </p:txBody>
           </p:sp>
           <p:sp>
             <p:nvSpPr>
@@ -11591,7 +12172,7 @@
               </a:ln>
               <a:extLst>
                 <a:ext uri="{91240B29-F687-4f45-9708-019B960494DF}">
-                  <a14:hiddenLine xmlns="" xmlns:a14="http://schemas.microsoft.com/office/drawing/2010/main" w="9525">
+                  <a14:hiddenLine xmlns:a14="http://schemas.microsoft.com/office/drawing/2010/main" xmlns="" w="9525">
                     <a:solidFill>
                       <a:srgbClr val="000000"/>
                     </a:solidFill>
@@ -11602,6 +12183,13 @@
                 </a:ext>
               </a:extLst>
             </p:spPr>
+            <p:txBody>
+              <a:bodyPr/>
+              <a:lstStyle/>
+              <a:p>
+                <a:endParaRPr lang="de-DE"/>
+              </a:p>
+            </p:txBody>
           </p:sp>
           <p:sp>
             <p:nvSpPr>
@@ -11656,7 +12244,7 @@
               </a:ln>
               <a:extLst>
                 <a:ext uri="{91240B29-F687-4f45-9708-019B960494DF}">
-                  <a14:hiddenLine xmlns="" xmlns:a14="http://schemas.microsoft.com/office/drawing/2010/main" w="9525">
+                  <a14:hiddenLine xmlns:a14="http://schemas.microsoft.com/office/drawing/2010/main" xmlns="" w="9525">
                     <a:solidFill>
                       <a:srgbClr val="000000"/>
                     </a:solidFill>
@@ -11667,6 +12255,13 @@
                 </a:ext>
               </a:extLst>
             </p:spPr>
+            <p:txBody>
+              <a:bodyPr/>
+              <a:lstStyle/>
+              <a:p>
+                <a:endParaRPr lang="de-DE"/>
+              </a:p>
+            </p:txBody>
           </p:sp>
           <p:sp>
             <p:nvSpPr>
@@ -11746,7 +12341,7 @@
               </a:ln>
               <a:extLst>
                 <a:ext uri="{91240B29-F687-4f45-9708-019B960494DF}">
-                  <a14:hiddenLine xmlns="" xmlns:a14="http://schemas.microsoft.com/office/drawing/2010/main" w="9525">
+                  <a14:hiddenLine xmlns:a14="http://schemas.microsoft.com/office/drawing/2010/main" xmlns="" w="9525">
                     <a:solidFill>
                       <a:srgbClr val="000000"/>
                     </a:solidFill>
@@ -11757,6 +12352,13 @@
                 </a:ext>
               </a:extLst>
             </p:spPr>
+            <p:txBody>
+              <a:bodyPr/>
+              <a:lstStyle/>
+              <a:p>
+                <a:endParaRPr lang="de-DE"/>
+              </a:p>
+            </p:txBody>
           </p:sp>
           <p:sp>
             <p:nvSpPr>
@@ -11814,7 +12416,7 @@
               </a:ln>
               <a:extLst>
                 <a:ext uri="{91240B29-F687-4f45-9708-019B960494DF}">
-                  <a14:hiddenLine xmlns="" xmlns:a14="http://schemas.microsoft.com/office/drawing/2010/main" w="9525">
+                  <a14:hiddenLine xmlns:a14="http://schemas.microsoft.com/office/drawing/2010/main" xmlns="" w="9525">
                     <a:solidFill>
                       <a:srgbClr val="000000"/>
                     </a:solidFill>
@@ -11825,6 +12427,13 @@
                 </a:ext>
               </a:extLst>
             </p:spPr>
+            <p:txBody>
+              <a:bodyPr/>
+              <a:lstStyle/>
+              <a:p>
+                <a:endParaRPr lang="de-DE"/>
+              </a:p>
+            </p:txBody>
           </p:sp>
           <p:sp>
             <p:nvSpPr>
@@ -11904,7 +12513,7 @@
               </a:ln>
               <a:extLst>
                 <a:ext uri="{91240B29-F687-4f45-9708-019B960494DF}">
-                  <a14:hiddenLine xmlns="" xmlns:a14="http://schemas.microsoft.com/office/drawing/2010/main" w="9525">
+                  <a14:hiddenLine xmlns:a14="http://schemas.microsoft.com/office/drawing/2010/main" xmlns="" w="9525">
                     <a:solidFill>
                       <a:srgbClr val="000000"/>
                     </a:solidFill>
@@ -11915,6 +12524,13 @@
                 </a:ext>
               </a:extLst>
             </p:spPr>
+            <p:txBody>
+              <a:bodyPr/>
+              <a:lstStyle/>
+              <a:p>
+                <a:endParaRPr lang="de-DE"/>
+              </a:p>
+            </p:txBody>
           </p:sp>
           <p:sp>
             <p:nvSpPr>
@@ -11972,7 +12588,7 @@
               </a:ln>
               <a:extLst>
                 <a:ext uri="{91240B29-F687-4f45-9708-019B960494DF}">
-                  <a14:hiddenLine xmlns="" xmlns:a14="http://schemas.microsoft.com/office/drawing/2010/main" w="9525">
+                  <a14:hiddenLine xmlns:a14="http://schemas.microsoft.com/office/drawing/2010/main" xmlns="" w="9525">
                     <a:solidFill>
                       <a:srgbClr val="000000"/>
                     </a:solidFill>
@@ -11983,6 +12599,13 @@
                 </a:ext>
               </a:extLst>
             </p:spPr>
+            <p:txBody>
+              <a:bodyPr/>
+              <a:lstStyle/>
+              <a:p>
+                <a:endParaRPr lang="de-DE"/>
+              </a:p>
+            </p:txBody>
           </p:sp>
           <p:sp>
             <p:nvSpPr>
@@ -12062,7 +12685,7 @@
               </a:ln>
               <a:extLst>
                 <a:ext uri="{91240B29-F687-4f45-9708-019B960494DF}">
-                  <a14:hiddenLine xmlns="" xmlns:a14="http://schemas.microsoft.com/office/drawing/2010/main" w="9525">
+                  <a14:hiddenLine xmlns:a14="http://schemas.microsoft.com/office/drawing/2010/main" xmlns="" w="9525">
                     <a:solidFill>
                       <a:srgbClr val="000000"/>
                     </a:solidFill>
@@ -12073,6 +12696,13 @@
                 </a:ext>
               </a:extLst>
             </p:spPr>
+            <p:txBody>
+              <a:bodyPr/>
+              <a:lstStyle/>
+              <a:p>
+                <a:endParaRPr lang="de-DE"/>
+              </a:p>
+            </p:txBody>
           </p:sp>
           <p:sp>
             <p:nvSpPr>
@@ -12096,7 +12726,7 @@
               </a:ln>
               <a:extLst>
                 <a:ext uri="{91240B29-F687-4f45-9708-019B960494DF}">
-                  <a14:hiddenLine xmlns="" xmlns:a14="http://schemas.microsoft.com/office/drawing/2010/main" w="9525">
+                  <a14:hiddenLine xmlns:a14="http://schemas.microsoft.com/office/drawing/2010/main" xmlns="" w="9525">
                     <a:solidFill>
                       <a:srgbClr val="000000"/>
                     </a:solidFill>
@@ -12107,6 +12737,13 @@
                 </a:ext>
               </a:extLst>
             </p:spPr>
+            <p:txBody>
+              <a:bodyPr/>
+              <a:lstStyle/>
+              <a:p>
+                <a:endParaRPr lang="de-DE"/>
+              </a:p>
+            </p:txBody>
           </p:sp>
         </p:grpSp>
       </p:grpSp>
@@ -12347,13 +12984,13 @@
     <p:sldLayoutId id="2147483730" r:id="rId16"/>
     <p:sldLayoutId id="2147483731" r:id="rId17"/>
   </p:sldLayoutIdLst>
-  <mc:AlternateContent xmlns:mc="http://schemas.openxmlformats.org/markup-compatibility/2006">
-    <mc:Choice xmlns:p14="http://schemas.microsoft.com/office/powerpoint/2010/main" Requires="p14">
+  <mc:AlternateContent xmlns:mc="http://schemas.openxmlformats.org/markup-compatibility/2006" xmlns:p14="http://schemas.microsoft.com/office/powerpoint/2010/main">
+    <mc:Choice Requires="p14">
       <p:transition spd="slow" p14:dur="1600">
         <p14:gallery dir="l"/>
       </p:transition>
     </mc:Choice>
-    <mc:Fallback>
+    <mc:Fallback xmlns="">
       <p:transition spd="slow">
         <p:fade/>
       </p:transition>
@@ -12773,13 +13410,13 @@
   <p:clrMapOvr>
     <a:masterClrMapping/>
   </p:clrMapOvr>
-  <mc:AlternateContent xmlns:mc="http://schemas.openxmlformats.org/markup-compatibility/2006">
-    <mc:Choice xmlns:p14="http://schemas.microsoft.com/office/powerpoint/2010/main" Requires="p14">
+  <mc:AlternateContent xmlns:mc="http://schemas.openxmlformats.org/markup-compatibility/2006" xmlns:p14="http://schemas.microsoft.com/office/powerpoint/2010/main">
+    <mc:Choice Requires="p14">
       <p:transition spd="slow" p14:dur="1600">
         <p14:gallery dir="l"/>
       </p:transition>
     </mc:Choice>
-    <mc:Fallback>
+    <mc:Fallback xmlns="">
       <p:transition spd="slow">
         <p:fade/>
       </p:transition>
@@ -12979,13 +13616,13 @@
   <p:clrMapOvr>
     <a:masterClrMapping/>
   </p:clrMapOvr>
-  <mc:AlternateContent xmlns:mc="http://schemas.openxmlformats.org/markup-compatibility/2006">
-    <mc:Choice xmlns:p14="http://schemas.microsoft.com/office/powerpoint/2010/main" Requires="p14">
+  <mc:AlternateContent xmlns:mc="http://schemas.openxmlformats.org/markup-compatibility/2006" xmlns:p14="http://schemas.microsoft.com/office/powerpoint/2010/main">
+    <mc:Choice Requires="p14">
       <p:transition spd="slow" p14:dur="1600">
         <p14:gallery dir="l"/>
       </p:transition>
     </mc:Choice>
-    <mc:Fallback>
+    <mc:Fallback xmlns="">
       <p:transition spd="slow">
         <p:fade/>
       </p:transition>
@@ -13318,13 +13955,13 @@
   <p:clrMapOvr>
     <a:masterClrMapping/>
   </p:clrMapOvr>
-  <mc:AlternateContent xmlns:mc="http://schemas.openxmlformats.org/markup-compatibility/2006">
-    <mc:Choice xmlns:p14="http://schemas.microsoft.com/office/powerpoint/2010/main" Requires="p14">
+  <mc:AlternateContent xmlns:mc="http://schemas.openxmlformats.org/markup-compatibility/2006" xmlns:p14="http://schemas.microsoft.com/office/powerpoint/2010/main">
+    <mc:Choice Requires="p14">
       <p:transition spd="slow" p14:dur="1600">
         <p14:gallery dir="l"/>
       </p:transition>
     </mc:Choice>
-    <mc:Fallback>
+    <mc:Fallback xmlns="">
       <p:transition spd="slow">
         <p:fade/>
       </p:transition>
@@ -13547,13 +14184,13 @@
   <p:clrMapOvr>
     <a:masterClrMapping/>
   </p:clrMapOvr>
-  <mc:AlternateContent xmlns:mc="http://schemas.openxmlformats.org/markup-compatibility/2006">
-    <mc:Choice xmlns:p14="http://schemas.microsoft.com/office/powerpoint/2010/main" Requires="p14">
+  <mc:AlternateContent xmlns:mc="http://schemas.openxmlformats.org/markup-compatibility/2006" xmlns:p14="http://schemas.microsoft.com/office/powerpoint/2010/main">
+    <mc:Choice Requires="p14">
       <p:transition spd="slow" p14:dur="1600">
         <p14:gallery dir="l"/>
       </p:transition>
     </mc:Choice>
-    <mc:Fallback>
+    <mc:Fallback xmlns="">
       <p:transition spd="slow">
         <p:fade/>
       </p:transition>
@@ -13852,13 +14489,13 @@
   <p:clrMapOvr>
     <a:masterClrMapping/>
   </p:clrMapOvr>
-  <mc:AlternateContent xmlns:mc="http://schemas.openxmlformats.org/markup-compatibility/2006">
-    <mc:Choice xmlns:p14="http://schemas.microsoft.com/office/powerpoint/2010/main" Requires="p14">
+  <mc:AlternateContent xmlns:mc="http://schemas.openxmlformats.org/markup-compatibility/2006" xmlns:p14="http://schemas.microsoft.com/office/powerpoint/2010/main">
+    <mc:Choice Requires="p14">
       <p:transition spd="slow" p14:dur="1600">
         <p14:gallery dir="l"/>
       </p:transition>
     </mc:Choice>
-    <mc:Fallback>
+    <mc:Fallback xmlns="">
       <p:transition spd="slow">
         <p:fade/>
       </p:transition>
@@ -13894,14 +14531,21 @@
             <p:ph type="title"/>
           </p:nvPr>
         </p:nvSpPr>
-        <p:spPr/>
+        <p:spPr>
+          <a:xfrm>
+            <a:off x="857250" y="117986"/>
+            <a:ext cx="7429499" cy="848391"/>
+          </a:xfrm>
+        </p:spPr>
         <p:txBody>
           <a:bodyPr/>
           <a:lstStyle/>
           <a:p>
             <a:r>
+              <a:rPr dirty="0" err="1"/>
               <a:t>Technologieübersicht</a:t>
             </a:r>
+            <a:endParaRPr dirty="0"/>
           </a:p>
         </p:txBody>
       </p:sp>
@@ -13917,13 +14561,13 @@
         </p:nvSpPr>
         <p:spPr>
           <a:xfrm>
-            <a:off x="973394" y="1600200"/>
-            <a:ext cx="7713406" cy="4898923"/>
+            <a:off x="973394" y="894736"/>
+            <a:ext cx="7713406" cy="5845278"/>
           </a:xfrm>
         </p:spPr>
         <p:txBody>
           <a:bodyPr>
-            <a:normAutofit fontScale="55000" lnSpcReduction="20000"/>
+            <a:normAutofit fontScale="47500" lnSpcReduction="20000"/>
           </a:bodyPr>
           <a:lstStyle/>
           <a:p>
@@ -13982,18 +14626,81 @@
               <a:buChar char="Ø"/>
             </a:pPr>
             <a:r>
+              <a:rPr lang="de-DE" dirty="0"/>
+              <a:t>n8n (Workflow-Automatisierung &amp; Orchestrierung) </a:t>
+            </a:r>
+          </a:p>
+          <a:p>
+            <a:pPr marL="0" indent="0">
+              <a:buNone/>
+            </a:pPr>
+            <a:r>
+              <a:rPr lang="de-DE" dirty="0"/>
+              <a:t>	Steuert und verknüpft alle Prozess-Schritte (</a:t>
+            </a:r>
+            <a:r>
+              <a:rPr lang="de-DE" dirty="0" err="1"/>
+              <a:t>Scraping</a:t>
+            </a:r>
+            <a:r>
+              <a:rPr lang="de-DE" dirty="0"/>
+              <a:t> → Extraktion → Speicherung → PDF). </a:t>
+            </a:r>
+          </a:p>
+          <a:p>
+            <a:pPr marL="0" indent="0">
+              <a:buNone/>
+            </a:pPr>
+            <a:r>
+              <a:rPr lang="de-DE" dirty="0"/>
+              <a:t>	Kann </a:t>
+            </a:r>
+            <a:r>
+              <a:rPr lang="de-DE" dirty="0" err="1"/>
+              <a:t>FastAPI</a:t>
+            </a:r>
+            <a:r>
+              <a:rPr lang="de-DE" dirty="0"/>
+              <a:t>, </a:t>
+            </a:r>
+            <a:r>
               <a:rPr lang="de-DE" dirty="0" err="1"/>
               <a:t>Playwright</a:t>
             </a:r>
             <a:r>
               <a:rPr lang="de-DE" dirty="0"/>
-              <a:t> + </a:t>
+              <a:t>/</a:t>
             </a:r>
             <a:r>
               <a:rPr lang="de-DE" dirty="0" err="1"/>
               <a:t>BeautifulSoup</a:t>
             </a:r>
-            <a:endParaRPr lang="de-DE" dirty="0"/>
+            <a:r>
+              <a:rPr lang="de-DE" dirty="0"/>
+              <a:t> und manuelle Skripte automatisieren bzw. auslösen.</a:t>
+            </a:r>
+          </a:p>
+          <a:p>
+            <a:pPr>
+              <a:buFont typeface="Wingdings" panose="05000000000000000000" pitchFamily="2" charset="2"/>
+              <a:buChar char="Ø"/>
+            </a:pPr>
+            <a:r>
+              <a:rPr lang="de-DE" dirty="0" err="1"/>
+              <a:t>Playwright</a:t>
+            </a:r>
+            <a:r>
+              <a:rPr lang="de-DE" dirty="0"/>
+              <a:t> + </a:t>
+            </a:r>
+            <a:r>
+              <a:rPr lang="de-DE" dirty="0" err="1"/>
+              <a:t>BeautifulSoup</a:t>
+            </a:r>
+            <a:r>
+              <a:rPr lang="de-DE" dirty="0"/>
+              <a:t> </a:t>
+            </a:r>
           </a:p>
           <a:p>
             <a:pPr marL="0" indent="0">
@@ -14154,13 +14861,13 @@
   <p:clrMapOvr>
     <a:masterClrMapping/>
   </p:clrMapOvr>
-  <mc:AlternateContent xmlns:mc="http://schemas.openxmlformats.org/markup-compatibility/2006">
-    <mc:Choice xmlns:p14="http://schemas.microsoft.com/office/powerpoint/2010/main" Requires="p14">
+  <mc:AlternateContent xmlns:mc="http://schemas.openxmlformats.org/markup-compatibility/2006" xmlns:p14="http://schemas.microsoft.com/office/powerpoint/2010/main">
+    <mc:Choice Requires="p14">
       <p:transition spd="slow" p14:dur="1600">
         <p14:gallery dir="l"/>
       </p:transition>
     </mc:Choice>
-    <mc:Fallback>
+    <mc:Fallback xmlns="">
       <p:transition spd="slow">
         <p:fade/>
       </p:transition>
@@ -14458,13 +15165,13 @@
   <p:clrMapOvr>
     <a:masterClrMapping/>
   </p:clrMapOvr>
-  <mc:AlternateContent xmlns:mc="http://schemas.openxmlformats.org/markup-compatibility/2006">
-    <mc:Choice xmlns:p14="http://schemas.microsoft.com/office/powerpoint/2010/main" Requires="p14">
+  <mc:AlternateContent xmlns:mc="http://schemas.openxmlformats.org/markup-compatibility/2006" xmlns:p14="http://schemas.microsoft.com/office/powerpoint/2010/main">
+    <mc:Choice Requires="p14">
       <p:transition spd="slow" p14:dur="1600">
         <p14:gallery dir="l"/>
       </p:transition>
     </mc:Choice>
-    <mc:Fallback>
+    <mc:Fallback xmlns="">
       <p:transition spd="slow">
         <p:fade/>
       </p:transition>
@@ -14648,13 +15355,13 @@
   <p:clrMapOvr>
     <a:masterClrMapping/>
   </p:clrMapOvr>
-  <mc:AlternateContent xmlns:mc="http://schemas.openxmlformats.org/markup-compatibility/2006">
-    <mc:Choice xmlns:p14="http://schemas.microsoft.com/office/powerpoint/2010/main" Requires="p14">
+  <mc:AlternateContent xmlns:mc="http://schemas.openxmlformats.org/markup-compatibility/2006" xmlns:p14="http://schemas.microsoft.com/office/powerpoint/2010/main">
+    <mc:Choice Requires="p14">
       <p:transition spd="slow" p14:dur="1600">
         <p14:gallery dir="l"/>
       </p:transition>
     </mc:Choice>
-    <mc:Fallback>
+    <mc:Fallback xmlns="">
       <p:transition spd="slow">
         <p:fade/>
       </p:transition>
@@ -14842,13 +15549,13 @@
   <p:clrMapOvr>
     <a:masterClrMapping/>
   </p:clrMapOvr>
-  <mc:AlternateContent xmlns:mc="http://schemas.openxmlformats.org/markup-compatibility/2006">
-    <mc:Choice xmlns:p14="http://schemas.microsoft.com/office/powerpoint/2010/main" Requires="p14">
+  <mc:AlternateContent xmlns:mc="http://schemas.openxmlformats.org/markup-compatibility/2006" xmlns:p14="http://schemas.microsoft.com/office/powerpoint/2010/main">
+    <mc:Choice Requires="p14">
       <p:transition spd="slow" p14:dur="1600">
         <p14:gallery dir="l"/>
       </p:transition>
     </mc:Choice>
-    <mc:Fallback>
+    <mc:Fallback xmlns="">
       <p:transition spd="slow">
         <p:fade/>
       </p:transition>

</xml_diff>